<commit_message>
Add second supervisor and qualitative-study details to deck and RD6 report
Second supervisor Dr Kia Dashtipour; the qualitative phase is described as
online interviews and round-table discussions with 20 infectious disease and
critical care consultants from different hospitals.

Co-Authored-By: Claude Opus 5.5 <noreply@anthropic.com>
Claude-Session: https://claude.ai/code/session_01LgDqxV9dzSvE8XpquGaBd5
</commit_message>
<xml_diff>
--- a/dev/presentation/Elrggal_Mahmoud_SCEBE2026.pptx
+++ b/dev/presentation/Elrggal_Mahmoud_SCEBE2026.pptx
@@ -131,7 +131,7 @@
   <p:extLst>
     <p:ext uri="{521415D9-36F7-43E2-AB2F-B90AF26B5E84}">
       <p14:sectionLst xmlns:p14="http://schemas.microsoft.com/office/powerpoint/2010/main">
-        <p14:section name="Context" id="{7f61cd52-da98-6bcf-61c2-05ef9fb1d69a}">
+        <p14:section name="Context" id="{94884aa3-261f-4bbe-c77b-2be97a35b419}">
           <p14:sldIdLst>
             <p14:sldId id="256"/>
             <p14:sldId id="257"/>
@@ -140,7 +140,7 @@
             <p14:sldId id="260"/>
           </p14:sldIdLst>
         </p14:section>
-        <p14:section name="Question and approach" id="{32058e3f-f41c-5ad1-cc73-49ff3ff19d3a}">
+        <p14:section name="Question and approach" id="{e3da23a0-d364-c07b-69ef-002d57a2e0db}">
           <p14:sldIdLst>
             <p14:sldId id="261"/>
             <p14:sldId id="262"/>
@@ -149,24 +149,24 @@
             <p14:sldId id="265"/>
           </p14:sldIdLst>
         </p14:section>
-        <p14:section name="Preliminary results" id="{0c0271dc-e591-5449-5757-bb71d5cdf61d}">
+        <p14:section name="Preliminary results" id="{eba2f41c-3064-c8c0-0dcb-9a71f13b2df7}">
           <p14:sldIdLst>
             <p14:sldId id="266"/>
             <p14:sldId id="267"/>
             <p14:sldId id="268"/>
           </p14:sldIdLst>
         </p14:section>
-        <p14:section name="Contribution and next steps" id="{7ece7724-fbb7-4a9e-da92-169d4434b4d9}">
+        <p14:section name="Contribution and next steps" id="{a2e33362-9618-3c47-82f4-a3f118374bea}">
           <p14:sldIdLst>
             <p14:sldId id="269"/>
           </p14:sldIdLst>
         </p14:section>
-        <p14:section name="Input" id="{887c2958-35b7-7f3e-cd90-fab94cdf1245}">
+        <p14:section name="Input" id="{e06b4947-75fc-9a7c-6c92-cdefc12ffefb}">
           <p14:sldIdLst>
             <p14:sldId id="270"/>
           </p14:sldIdLst>
         </p14:section>
-        <p14:section name="Backup" id="{02debc45-9608-0574-581b-4cef58cea908}">
+        <p14:section name="Backup" id="{bb76348b-caea-ab76-0e20-ee0bf2f8accf}">
           <p14:sldIdLst>
             <p14:sldId id="271"/>
             <p14:sldId id="272"/>
@@ -5169,7 +5169,7 @@
                   <a:srgbClr val="1B1B1B"/>
                 </a:solidFill>
               </a:rPr>
-              <a:t>Second Supervisor: Kia</a:t>
+              <a:t>Second Supervisor: Dr Kia Dashtipour</a:t>
             </a:r>
             <a:endParaRPr lang="en-US" sz="1800" dirty="0"/>
           </a:p>
@@ -10406,7 +10406,7 @@
                   <a:srgbClr val="1B1B1B"/>
                 </a:solidFill>
               </a:rPr>
-              <a:t>Complete the qualitative study with healthcare professionals; finish the 16-model comparison</a:t>
+              <a:t>Complete the qualitative study (20 infectious disease and critical care consultants); finish the 16-model comparison</a:t>
             </a:r>
             <a:endParaRPr lang="en-US" sz="1300" dirty="0"/>
           </a:p>
@@ -19758,7 +19758,7 @@
                   <a:srgbClr val="1B1B1B"/>
                 </a:solidFill>
               </a:rPr>
-              <a:t>Clinician study: now the qualitative phase, in progress.</a:t>
+              <a:t>Clinician study: now the qualitative phase (20 consultants), nearly complete.</a:t>
             </a:r>
             <a:endParaRPr lang="en-US" sz="1350" dirty="0"/>
           </a:p>
@@ -27391,14 +27391,14 @@
               <a:buNone/>
             </a:pPr>
             <a:r>
-              <a:rPr lang="en-US" sz="1250" dirty="0">
+              <a:rPr lang="en-US" sz="1200" dirty="0">
                 <a:solidFill>
                   <a:srgbClr val="1B1B1B"/>
                 </a:solidFill>
               </a:rPr>
-              <a:t>Healthcare professionals: would they trust and act on the alert, what explanation do they need, what alarm burden is acceptable [26].</a:t>
-            </a:r>
-            <a:endParaRPr lang="en-US" sz="1250" dirty="0"/>
+              <a:t>Online interviews and round-table discussions with 20 infectious disease and critical care consultants from different hospitals: would they trust and act on the alert, what explanation do they need, what alarm burden is acceptable [26].</a:t>
+            </a:r>
+            <a:endParaRPr lang="en-US" sz="1200" dirty="0"/>
           </a:p>
         </p:txBody>
       </p:sp>

</xml_diff>

<commit_message>
Presentation and RD6 report: completed MIMIC-IV development comparison results
Slide 13 and the overfitting backup now show the 21-model comparison
(all utilities above zero, OSTA 0.23, winner's method 0.15, GRU-D chosen
on validation 0.19). RD6 sections 4.4-4.5 and the conclusion carry the
same results, the prespecified decisions and the eICU transfer finding.

Co-Authored-By: Claude Opus 5.5 <noreply@anthropic.com>
Claude-Session: https://claude.ai/code/session_01LgDqxV9dzSvE8XpquGaBd5
</commit_message>
<xml_diff>
--- a/dev/presentation/Elrggal_Mahmoud_SCEBE2026.pptx
+++ b/dev/presentation/Elrggal_Mahmoud_SCEBE2026.pptx
@@ -131,7 +131,7 @@
   <p:extLst>
     <p:ext uri="{521415D9-36F7-43E2-AB2F-B90AF26B5E84}">
       <p14:sectionLst xmlns:p14="http://schemas.microsoft.com/office/powerpoint/2010/main">
-        <p14:section name="Context" id="{94884aa3-261f-4bbe-c77b-2be97a35b419}">
+        <p14:section name="Context" id="{eaf57215-b968-68ae-957a-b2fea3dbd97c}">
           <p14:sldIdLst>
             <p14:sldId id="256"/>
             <p14:sldId id="257"/>
@@ -140,7 +140,7 @@
             <p14:sldId id="260"/>
           </p14:sldIdLst>
         </p14:section>
-        <p14:section name="Question and approach" id="{e3da23a0-d364-c07b-69ef-002d57a2e0db}">
+        <p14:section name="Question and approach" id="{218615e4-fc27-aa34-5ce1-ffb161400dad}">
           <p14:sldIdLst>
             <p14:sldId id="261"/>
             <p14:sldId id="262"/>
@@ -149,24 +149,24 @@
             <p14:sldId id="265"/>
           </p14:sldIdLst>
         </p14:section>
-        <p14:section name="Preliminary results" id="{eba2f41c-3064-c8c0-0dcb-9a71f13b2df7}">
+        <p14:section name="Preliminary results" id="{cd3cc274-6744-c7cd-24da-c8e7323da6cb}">
           <p14:sldIdLst>
             <p14:sldId id="266"/>
             <p14:sldId id="267"/>
             <p14:sldId id="268"/>
           </p14:sldIdLst>
         </p14:section>
-        <p14:section name="Contribution and next steps" id="{a2e33362-9618-3c47-82f4-a3f118374bea}">
+        <p14:section name="Contribution and next steps" id="{e56940e4-5816-69fe-cadf-22fb9c016459}">
           <p14:sldIdLst>
             <p14:sldId id="269"/>
           </p14:sldIdLst>
         </p14:section>
-        <p14:section name="Input" id="{e06b4947-75fc-9a7c-6c92-cdefc12ffefb}">
+        <p14:section name="Input" id="{a64a9846-2220-233b-9ee1-dc25cb4cc983}">
           <p14:sldIdLst>
             <p14:sldId id="270"/>
           </p14:sldIdLst>
         </p14:section>
-        <p14:section name="Backup" id="{bb76348b-caea-ab76-0e20-ee0bf2f8accf}">
+        <p14:section name="Backup" id="{9818f1a3-2f85-9d30-340d-2a94800a4c6d}">
           <p14:sldIdLst>
             <p14:sldId id="271"/>
             <p14:sldId id="272"/>
@@ -714,7 +714,7 @@
             <c:bubble3D val="0"/>
             <c:spPr>
               <a:solidFill>
-                <a:srgbClr val="C8102E"/>
+                <a:srgbClr val="3A3A3A"/>
               </a:solidFill>
               <a:effectLst/>
             </c:spPr>
@@ -730,23 +730,37 @@
               <a:effectLst/>
             </c:spPr>
           </c:dPt>
+          <c:dPt>
+            <c:idx val="4"/>
+            <c:invertIfNegative val="0"/>
+            <c:bubble3D val="0"/>
+            <c:spPr>
+              <a:solidFill>
+                <a:srgbClr val="C8102E"/>
+              </a:solidFill>
+              <a:effectLst/>
+            </c:spPr>
+          </c:dPt>
           <c:cat>
             <c:multiLvlStrRef>
-              <c:f>Sheet1!$A$2:$A$5</c:f>
+              <c:f>Sheet1!$A$2:$A$6</c:f>
               <c:multiLvlStrCache>
-                <c:ptCount val="4"/>
+                <c:ptCount val="5"/>
                 <c:lvl>
                   <c:pt idx="0">
-                    <c:v>Winner, new patients, its 2 hospitals</c:v>
+                    <c:v>Winner, published: its 2 hospitals</c:v>
                   </c:pt>
                   <c:pt idx="1">
-                    <c:v>Winner, unseen third hospital</c:v>
+                    <c:v>Winner, published: unseen hospital</c:v>
                   </c:pt>
                   <c:pt idx="2">
-                    <c:v>Our causal OSTA, PhysioNet test</c:v>
+                    <c:v>Winner's method, rebuilt here</c:v>
                   </c:pt>
                   <c:pt idx="3">
-                    <c:v>Our best model, MIMIC-IV development test</c:v>
+                    <c:v>OSTA (this project)</c:v>
+                  </c:pt>
+                  <c:pt idx="4">
+                    <c:v>GRU-D (chosen on validation)</c:v>
                   </c:pt>
                 </c:lvl>
               </c:multiLvlStrCache>
@@ -754,10 +768,10 @@
           </c:cat>
           <c:val>
             <c:numRef>
-              <c:f>Sheet1!$B$2:$B$5</c:f>
+              <c:f>Sheet1!$B$2:$B$6</c:f>
               <c:numCache>
                 <c:formatCode>General</c:formatCode>
-                <c:ptCount val="4"/>
+                <c:ptCount val="5"/>
                 <c:pt idx="0">
                   <c:v>0.43</c:v>
                 </c:pt>
@@ -765,10 +779,13 @@
                   <c:v>-0.12</c:v>
                 </c:pt>
                 <c:pt idx="2">
-                  <c:v>0.22</c:v>
+                  <c:v>0.15</c:v>
                 </c:pt>
                 <c:pt idx="3">
-                  <c:v>0.18</c:v>
+                  <c:v>0.23</c:v>
+                </c:pt>
+                <c:pt idx="4">
+                  <c:v>0.19</c:v>
                 </c:pt>
               </c:numCache>
             </c:numRef>
@@ -798,7 +815,7 @@
           <c:showBubbleSize val="0"/>
           <c:showLeaderLines val="0"/>
         </c:dLbls>
-        <c:gapWidth val="45"/>
+        <c:gapWidth val="40"/>
         <c:overlap val="0"/>
         <c:axId val="2094734554"/>
         <c:axId val="2094734552"/>
@@ -2175,7 +2192,7 @@
           <a:p>
             <a:r>
               <a:rPr lang="en-US" dirty="0"/>
-              <a:t>1 min. Grey is the published winner: 0.43 on new patients from the hospitals it trained on, minus 0.12 on a hospital it had never seen. Red is this project. The point is not that 0.18 is high; it is positive, with its confidence interval above zero, on raw data scored causally. Say the caveats: preliminary, development split, holdout sealed.</a:t>
+              <a:t>1 min. Grey is the published winner: 0.43 on its own hospitals, minus 0.12 on an unseen one. Dark grey is the winner's own method rebuilt in our causal pipeline on MIMIC-IV: 0.15. Red is this project: OSTA 0.23, and GRU-D, the model the prespecified rule chose on validation, 0.19. All 21 models have positive utility with confidence intervals above zero. The organ grouping did not beat the same model without it at this sample size; that is reported as found. Say: preliminary, one run, development split.</a:t>
             </a:r>
             <a:endParaRPr lang="en-US" dirty="0"/>
           </a:p>
@@ -9011,7 +9028,7 @@
                 <a:ea typeface="Arial" pitchFamily="34" charset="-122"/>
                 <a:cs typeface="Arial" pitchFamily="34" charset="-120"/>
               </a:rPr>
-              <a:t>Result 3: positive utility on MIMIC-IV, where the challenge winner fell below zero on an unseen hospital</a:t>
+              <a:t>Result 3: on identical MIMIC-IV hours, all 21 models have positive utility, including the winner's method</a:t>
             </a:r>
             <a:endParaRPr lang="en-US" sz="2600" dirty="0"/>
           </a:p>
@@ -9041,7 +9058,7 @@
         </p:nvSpPr>
         <p:spPr>
           <a:xfrm>
-            <a:off x="822960" y="5532120"/>
+            <a:off x="640080" y="5532120"/>
             <a:ext cx="228600" cy="182880"/>
           </a:xfrm>
           <a:prstGeom prst="rect">
@@ -9066,8 +9083,8 @@
         </p:nvSpPr>
         <p:spPr>
           <a:xfrm>
-            <a:off x="1115568" y="5486400"/>
-            <a:ext cx="3017520" cy="274320"/>
+            <a:off x="932688" y="5486400"/>
+            <a:ext cx="1737360" cy="274320"/>
           </a:xfrm>
           <a:prstGeom prst="rect">
             <a:avLst/>
@@ -9088,7 +9105,7 @@
                   <a:srgbClr val="1B1B1B"/>
                 </a:solidFill>
               </a:rPr>
-              <a:t>Published challenge winner [15, 21]</a:t>
+              <a:t>Published [15, 21]</a:t>
             </a:r>
             <a:endParaRPr lang="en-US" sz="1200" dirty="0"/>
           </a:p>
@@ -9102,7 +9119,68 @@
         </p:nvSpPr>
         <p:spPr>
           <a:xfrm>
-            <a:off x="4206240" y="5532120"/>
+            <a:off x="2651760" y="5532120"/>
+            <a:ext cx="228600" cy="182880"/>
+          </a:xfrm>
+          <a:prstGeom prst="rect">
+            <a:avLst/>
+          </a:prstGeom>
+          <a:solidFill>
+            <a:srgbClr val="3A3A3A"/>
+          </a:solidFill>
+          <a:ln w="12700">
+            <a:solidFill>
+              <a:srgbClr val="3A3A3A"/>
+            </a:solidFill>
+            <a:prstDash val="solid"/>
+          </a:ln>
+        </p:spPr>
+      </p:sp>
+      <p:sp>
+        <p:nvSpPr>
+          <p:cNvPr id="10" name="text"/>
+          <p:cNvSpPr txBox="1"/>
+          <p:nvPr/>
+        </p:nvSpPr>
+        <p:spPr>
+          <a:xfrm>
+            <a:off x="2944368" y="5486400"/>
+            <a:ext cx="2286000" cy="274320"/>
+          </a:xfrm>
+          <a:prstGeom prst="rect">
+            <a:avLst/>
+          </a:prstGeom>
+          <a:noFill/>
+          <a:ln/>
+        </p:spPr>
+        <p:txBody>
+          <a:bodyPr wrap="square" lIns="0" tIns="0" rIns="0" bIns="0" rtlCol="0" anchor="ctr"/>
+          <a:lstStyle/>
+          <a:p>
+            <a:pPr algn="l" indent="0" marL="0">
+              <a:buNone/>
+            </a:pPr>
+            <a:r>
+              <a:rPr lang="en-US" sz="1200" dirty="0">
+                <a:solidFill>
+                  <a:srgbClr val="1B1B1B"/>
+                </a:solidFill>
+              </a:rPr>
+              <a:t>Winner's method, our pipeline</a:t>
+            </a:r>
+            <a:endParaRPr lang="en-US" sz="1200" dirty="0"/>
+          </a:p>
+        </p:txBody>
+      </p:sp>
+      <p:sp>
+        <p:nvSpPr>
+          <p:cNvPr id="11" name="legend swatch"/>
+          <p:cNvSpPr/>
+          <p:nvPr/>
+        </p:nvSpPr>
+        <p:spPr>
+          <a:xfrm>
+            <a:off x="5212080" y="5532120"/>
             <a:ext cx="228600" cy="182880"/>
           </a:xfrm>
           <a:prstGeom prst="rect">
@@ -9121,14 +9199,14 @@
       </p:sp>
       <p:sp>
         <p:nvSpPr>
-          <p:cNvPr id="10" name="text"/>
-          <p:cNvSpPr txBox="1"/>
-          <p:nvPr/>
-        </p:nvSpPr>
-        <p:spPr>
-          <a:xfrm>
-            <a:off x="4498848" y="5486400"/>
-            <a:ext cx="2834640" cy="274320"/>
+          <p:cNvPr id="12" name="text"/>
+          <p:cNvSpPr txBox="1"/>
+          <p:nvPr/>
+        </p:nvSpPr>
+        <p:spPr>
+          <a:xfrm>
+            <a:off x="5504688" y="5486400"/>
+            <a:ext cx="1828800" cy="274320"/>
           </a:xfrm>
           <a:prstGeom prst="rect">
             <a:avLst/>
@@ -9149,7 +9227,7 @@
                   <a:srgbClr val="1B1B1B"/>
                 </a:solidFill>
               </a:rPr>
-              <a:t>This project, causal evaluation [41]</a:t>
+              <a:t>This project [41]</a:t>
             </a:r>
             <a:endParaRPr lang="en-US" sz="1200" dirty="0"/>
           </a:p>
@@ -9157,7 +9235,7 @@
       </p:sp>
       <p:sp>
         <p:nvSpPr>
-          <p:cNvPr id="11" name="box"/>
+          <p:cNvPr id="13" name="box"/>
           <p:cNvSpPr/>
           <p:nvPr/>
         </p:nvSpPr>
@@ -9182,7 +9260,7 @@
       </p:sp>
       <p:sp>
         <p:nvSpPr>
-          <p:cNvPr id="12" name="text"/>
+          <p:cNvPr id="14" name="text"/>
           <p:cNvSpPr txBox="1"/>
           <p:nvPr/>
         </p:nvSpPr>
@@ -9218,7 +9296,7 @@
       </p:sp>
       <p:sp>
         <p:nvSpPr>
-          <p:cNvPr id="13" name="text"/>
+          <p:cNvPr id="15" name="text"/>
           <p:cNvSpPr txBox="1"/>
           <p:nvPr/>
         </p:nvSpPr>
@@ -9246,7 +9324,7 @@
                   <a:srgbClr val="5E5E5E"/>
                 </a:solidFill>
               </a:rPr>
-              <a:t>1,422 stays, 63,488 hours, 71 sepsis events</a:t>
+              <a:t>1,422 stays, 71 sepsis events, identical hours</a:t>
             </a:r>
             <a:endParaRPr lang="en-US" sz="1200" dirty="0"/>
           </a:p>
@@ -9254,14 +9332,14 @@
       </p:sp>
       <p:sp>
         <p:nvSpPr>
-          <p:cNvPr id="14" name="text"/>
-          <p:cNvSpPr txBox="1"/>
-          <p:nvPr/>
-        </p:nvSpPr>
-        <p:spPr>
-          <a:xfrm>
-            <a:off x="7726680" y="2331720"/>
-            <a:ext cx="1821028" cy="548640"/>
+          <p:cNvPr id="16" name="text"/>
+          <p:cNvSpPr txBox="1"/>
+          <p:nvPr/>
+        </p:nvSpPr>
+        <p:spPr>
+          <a:xfrm>
+            <a:off x="7726680" y="2286000"/>
+            <a:ext cx="1821028" cy="502920"/>
           </a:xfrm>
           <a:prstGeom prst="rect">
             <a:avLst/>
@@ -9277,12 +9355,156 @@
               <a:buNone/>
             </a:pPr>
             <a:r>
+              <a:rPr lang="en-US" sz="2200" b="1" dirty="0">
+                <a:solidFill>
+                  <a:srgbClr val="C8102E"/>
+                </a:solidFill>
+              </a:rPr>
+              <a:t>21 / 21</a:t>
+            </a:r>
+            <a:endParaRPr lang="en-US" sz="2200" dirty="0"/>
+          </a:p>
+        </p:txBody>
+      </p:sp>
+      <p:sp>
+        <p:nvSpPr>
+          <p:cNvPr id="17" name="text"/>
+          <p:cNvSpPr txBox="1"/>
+          <p:nvPr/>
+        </p:nvSpPr>
+        <p:spPr>
+          <a:xfrm>
+            <a:off x="7726680" y="2788920"/>
+            <a:ext cx="1775308" cy="640080"/>
+          </a:xfrm>
+          <a:prstGeom prst="rect">
+            <a:avLst/>
+          </a:prstGeom>
+          <a:noFill/>
+          <a:ln/>
+        </p:spPr>
+        <p:txBody>
+          <a:bodyPr wrap="square" lIns="0" tIns="0" rIns="0" bIns="0" rtlCol="0" anchor="t"/>
+          <a:lstStyle/>
+          <a:p>
+            <a:pPr algn="l" indent="0" marL="0">
+              <a:buNone/>
+            </a:pPr>
+            <a:r>
+              <a:rPr lang="en-US" sz="1150" dirty="0">
+                <a:solidFill>
+                  <a:srgbClr val="1B1B1B"/>
+                </a:solidFill>
+              </a:rPr>
+              <a:t>models with utility above zero, every 95 % CI above zero</a:t>
+            </a:r>
+            <a:endParaRPr lang="en-US" sz="1150" dirty="0"/>
+          </a:p>
+        </p:txBody>
+      </p:sp>
+      <p:sp>
+        <p:nvSpPr>
+          <p:cNvPr id="18" name="text"/>
+          <p:cNvSpPr txBox="1"/>
+          <p:nvPr/>
+        </p:nvSpPr>
+        <p:spPr>
+          <a:xfrm>
+            <a:off x="9593428" y="2286000"/>
+            <a:ext cx="1821028" cy="502920"/>
+          </a:xfrm>
+          <a:prstGeom prst="rect">
+            <a:avLst/>
+          </a:prstGeom>
+          <a:noFill/>
+          <a:ln/>
+        </p:spPr>
+        <p:txBody>
+          <a:bodyPr wrap="square" lIns="0" tIns="0" rIns="0" bIns="0" rtlCol="0" anchor="t"/>
+          <a:lstStyle/>
+          <a:p>
+            <a:pPr algn="l" indent="0" marL="0">
+              <a:buNone/>
+            </a:pPr>
+            <a:r>
+              <a:rPr lang="en-US" sz="2200" b="1" dirty="0">
+                <a:solidFill>
+                  <a:srgbClr val="C8102E"/>
+                </a:solidFill>
+              </a:rPr>
+              <a:t>0.08-0.29</a:t>
+            </a:r>
+            <a:endParaRPr lang="en-US" sz="2200" dirty="0"/>
+          </a:p>
+        </p:txBody>
+      </p:sp>
+      <p:sp>
+        <p:nvSpPr>
+          <p:cNvPr id="19" name="text"/>
+          <p:cNvSpPr txBox="1"/>
+          <p:nvPr/>
+        </p:nvSpPr>
+        <p:spPr>
+          <a:xfrm>
+            <a:off x="9593428" y="2788920"/>
+            <a:ext cx="1775308" cy="640080"/>
+          </a:xfrm>
+          <a:prstGeom prst="rect">
+            <a:avLst/>
+          </a:prstGeom>
+          <a:noFill/>
+          <a:ln/>
+        </p:spPr>
+        <p:txBody>
+          <a:bodyPr wrap="square" lIns="0" tIns="0" rIns="0" bIns="0" rtlCol="0" anchor="t"/>
+          <a:lstStyle/>
+          <a:p>
+            <a:pPr algn="l" indent="0" marL="0">
+              <a:buNone/>
+            </a:pPr>
+            <a:r>
+              <a:rPr lang="en-US" sz="1150" dirty="0">
+                <a:solidFill>
+                  <a:srgbClr val="1B1B1B"/>
+                </a:solidFill>
+              </a:rPr>
+              <a:t>utility range across all models</a:t>
+            </a:r>
+            <a:endParaRPr lang="en-US" sz="1150" dirty="0"/>
+          </a:p>
+        </p:txBody>
+      </p:sp>
+      <p:sp>
+        <p:nvSpPr>
+          <p:cNvPr id="20" name="text"/>
+          <p:cNvSpPr txBox="1"/>
+          <p:nvPr/>
+        </p:nvSpPr>
+        <p:spPr>
+          <a:xfrm>
+            <a:off x="7726680" y="3474720"/>
+            <a:ext cx="1821028" cy="502920"/>
+          </a:xfrm>
+          <a:prstGeom prst="rect">
+            <a:avLst/>
+          </a:prstGeom>
+          <a:noFill/>
+          <a:ln/>
+        </p:spPr>
+        <p:txBody>
+          <a:bodyPr wrap="square" lIns="0" tIns="0" rIns="0" bIns="0" rtlCol="0" anchor="t"/>
+          <a:lstStyle/>
+          <a:p>
+            <a:pPr algn="l" indent="0" marL="0">
+              <a:buNone/>
+            </a:pPr>
+            <a:r>
               <a:rPr lang="en-US" sz="2800" b="1" dirty="0">
                 <a:solidFill>
                   <a:srgbClr val="C8102E"/>
                 </a:solidFill>
               </a:rPr>
-              <a:t>0.81</a:t>
+              <a:t>0.23</a:t>
             </a:r>
             <a:endParaRPr lang="en-US" sz="2800" dirty="0"/>
           </a:p>
@@ -9290,14 +9512,14 @@
       </p:sp>
       <p:sp>
         <p:nvSpPr>
-          <p:cNvPr id="15" name="text"/>
-          <p:cNvSpPr txBox="1"/>
-          <p:nvPr/>
-        </p:nvSpPr>
-        <p:spPr>
-          <a:xfrm>
-            <a:off x="7726680" y="2880360"/>
-            <a:ext cx="1775308" cy="548640"/>
+          <p:cNvPr id="21" name="text"/>
+          <p:cNvSpPr txBox="1"/>
+          <p:nvPr/>
+        </p:nvSpPr>
+        <p:spPr>
+          <a:xfrm>
+            <a:off x="7726680" y="3977640"/>
+            <a:ext cx="1775308" cy="640080"/>
           </a:xfrm>
           <a:prstGeom prst="rect">
             <a:avLst/>
@@ -9313,27 +9535,27 @@
               <a:buNone/>
             </a:pPr>
             <a:r>
-              <a:rPr lang="en-US" sz="1200" dirty="0">
+              <a:rPr lang="en-US" sz="1150" dirty="0">
                 <a:solidFill>
                   <a:srgbClr val="1B1B1B"/>
                 </a:solidFill>
               </a:rPr>
-              <a:t>hourly AUROC, 3 seeds</a:t>
-            </a:r>
-            <a:endParaRPr lang="en-US" sz="1200" dirty="0"/>
-          </a:p>
-        </p:txBody>
-      </p:sp>
-      <p:sp>
-        <p:nvSpPr>
-          <p:cNvPr id="16" name="text"/>
-          <p:cNvSpPr txBox="1"/>
-          <p:nvPr/>
-        </p:nvSpPr>
-        <p:spPr>
-          <a:xfrm>
-            <a:off x="9593428" y="2331720"/>
-            <a:ext cx="1821028" cy="548640"/>
+              <a:t>OSTA, 95 % CI 0.13 to 0.34</a:t>
+            </a:r>
+            <a:endParaRPr lang="en-US" sz="1150" dirty="0"/>
+          </a:p>
+        </p:txBody>
+      </p:sp>
+      <p:sp>
+        <p:nvSpPr>
+          <p:cNvPr id="22" name="text"/>
+          <p:cNvSpPr txBox="1"/>
+          <p:nvPr/>
+        </p:nvSpPr>
+        <p:spPr>
+          <a:xfrm>
+            <a:off x="9593428" y="3474720"/>
+            <a:ext cx="1821028" cy="502920"/>
           </a:xfrm>
           <a:prstGeom prst="rect">
             <a:avLst/>
@@ -9354,7 +9576,7 @@
                   <a:srgbClr val="C8102E"/>
                 </a:solidFill>
               </a:rPr>
-              <a:t>5 h</a:t>
+              <a:t>0.15</a:t>
             </a:r>
             <a:endParaRPr lang="en-US" sz="2800" dirty="0"/>
           </a:p>
@@ -9362,14 +9584,14 @@
       </p:sp>
       <p:sp>
         <p:nvSpPr>
-          <p:cNvPr id="17" name="text"/>
-          <p:cNvSpPr txBox="1"/>
-          <p:nvPr/>
-        </p:nvSpPr>
-        <p:spPr>
-          <a:xfrm>
-            <a:off x="9593428" y="2880360"/>
-            <a:ext cx="1775308" cy="548640"/>
+          <p:cNvPr id="23" name="text"/>
+          <p:cNvSpPr txBox="1"/>
+          <p:nvPr/>
+        </p:nvSpPr>
+        <p:spPr>
+          <a:xfrm>
+            <a:off x="9593428" y="3977640"/>
+            <a:ext cx="1775308" cy="640080"/>
           </a:xfrm>
           <a:prstGeom prst="rect">
             <a:avLst/>
@@ -9385,27 +9607,27 @@
               <a:buNone/>
             </a:pPr>
             <a:r>
-              <a:rPr lang="en-US" sz="1200" dirty="0">
+              <a:rPr lang="en-US" sz="1150" dirty="0">
                 <a:solidFill>
                   <a:srgbClr val="1B1B1B"/>
                 </a:solidFill>
               </a:rPr>
-              <a:t>median warning before onset</a:t>
-            </a:r>
-            <a:endParaRPr lang="en-US" sz="1200" dirty="0"/>
-          </a:p>
-        </p:txBody>
-      </p:sp>
-      <p:sp>
-        <p:nvSpPr>
-          <p:cNvPr id="18" name="text"/>
-          <p:cNvSpPr txBox="1"/>
-          <p:nvPr/>
-        </p:nvSpPr>
-        <p:spPr>
-          <a:xfrm>
-            <a:off x="7726680" y="3566160"/>
-            <a:ext cx="1821028" cy="548640"/>
+              <a:t>winner's method, 95 % CI 0.06 to 0.22</a:t>
+            </a:r>
+            <a:endParaRPr lang="en-US" sz="1150" dirty="0"/>
+          </a:p>
+        </p:txBody>
+      </p:sp>
+      <p:sp>
+        <p:nvSpPr>
+          <p:cNvPr id="24" name="text"/>
+          <p:cNvSpPr txBox="1"/>
+          <p:nvPr/>
+        </p:nvSpPr>
+        <p:spPr>
+          <a:xfrm>
+            <a:off x="7726680" y="4709160"/>
+            <a:ext cx="3733495" cy="1005840"/>
           </a:xfrm>
           <a:prstGeom prst="rect">
             <a:avLst/>
@@ -9421,164 +9643,20 @@
               <a:buNone/>
             </a:pPr>
             <a:r>
-              <a:rPr lang="en-US" sz="2800" b="1" dirty="0">
-                <a:solidFill>
-                  <a:srgbClr val="C8102E"/>
-                </a:solidFill>
-              </a:rPr>
-              <a:t>1 in 2</a:t>
-            </a:r>
-            <a:endParaRPr lang="en-US" sz="2800" dirty="0"/>
-          </a:p>
-        </p:txBody>
-      </p:sp>
-      <p:sp>
-        <p:nvSpPr>
-          <p:cNvPr id="19" name="text"/>
-          <p:cNvSpPr txBox="1"/>
-          <p:nvPr/>
-        </p:nvSpPr>
-        <p:spPr>
-          <a:xfrm>
-            <a:off x="7726680" y="4114800"/>
-            <a:ext cx="1775308" cy="548640"/>
-          </a:xfrm>
-          <a:prstGeom prst="rect">
-            <a:avLst/>
-          </a:prstGeom>
-          <a:noFill/>
-          <a:ln/>
-        </p:spPr>
-        <p:txBody>
-          <a:bodyPr wrap="square" lIns="0" tIns="0" rIns="0" bIns="0" rtlCol="0" anchor="t"/>
-          <a:lstStyle/>
-          <a:p>
-            <a:pPr algn="l" indent="0" marL="0">
-              <a:buNone/>
-            </a:pPr>
-            <a:r>
-              <a:rPr lang="en-US" sz="1200" dirty="0">
-                <a:solidFill>
-                  <a:srgbClr val="1B1B1B"/>
-                </a:solidFill>
-              </a:rPr>
-              <a:t>sepsis events caught at 0.5 false alarms a day</a:t>
-            </a:r>
-            <a:endParaRPr lang="en-US" sz="1200" dirty="0"/>
-          </a:p>
-        </p:txBody>
-      </p:sp>
-      <p:sp>
-        <p:nvSpPr>
-          <p:cNvPr id="20" name="text"/>
-          <p:cNvSpPr txBox="1"/>
-          <p:nvPr/>
-        </p:nvSpPr>
-        <p:spPr>
-          <a:xfrm>
-            <a:off x="9593428" y="3566160"/>
-            <a:ext cx="1821028" cy="548640"/>
-          </a:xfrm>
-          <a:prstGeom prst="rect">
-            <a:avLst/>
-          </a:prstGeom>
-          <a:noFill/>
-          <a:ln/>
-        </p:spPr>
-        <p:txBody>
-          <a:bodyPr wrap="square" lIns="0" tIns="0" rIns="0" bIns="0" rtlCol="0" anchor="t"/>
-          <a:lstStyle/>
-          <a:p>
-            <a:pPr algn="l" indent="0" marL="0">
-              <a:buNone/>
-            </a:pPr>
-            <a:r>
-              <a:rPr lang="en-US" sz="2200" b="1" dirty="0">
-                <a:solidFill>
-                  <a:srgbClr val="C8102E"/>
-                </a:solidFill>
-              </a:rPr>
-              <a:t>0.08-0.27</a:t>
-            </a:r>
-            <a:endParaRPr lang="en-US" sz="2200" dirty="0"/>
-          </a:p>
-        </p:txBody>
-      </p:sp>
-      <p:sp>
-        <p:nvSpPr>
-          <p:cNvPr id="21" name="text"/>
-          <p:cNvSpPr txBox="1"/>
-          <p:nvPr/>
-        </p:nvSpPr>
-        <p:spPr>
-          <a:xfrm>
-            <a:off x="9593428" y="4114800"/>
-            <a:ext cx="1775308" cy="548640"/>
-          </a:xfrm>
-          <a:prstGeom prst="rect">
-            <a:avLst/>
-          </a:prstGeom>
-          <a:noFill/>
-          <a:ln/>
-        </p:spPr>
-        <p:txBody>
-          <a:bodyPr wrap="square" lIns="0" tIns="0" rIns="0" bIns="0" rtlCol="0" anchor="t"/>
-          <a:lstStyle/>
-          <a:p>
-            <a:pPr algn="l" indent="0" marL="0">
-              <a:buNone/>
-            </a:pPr>
-            <a:r>
-              <a:rPr lang="en-US" sz="1200" dirty="0">
-                <a:solidFill>
-                  <a:srgbClr val="1B1B1B"/>
-                </a:solidFill>
-              </a:rPr>
-              <a:t>95 % CI of utility 0.18</a:t>
-            </a:r>
-            <a:endParaRPr lang="en-US" sz="1200" dirty="0"/>
-          </a:p>
-        </p:txBody>
-      </p:sp>
-      <p:sp>
-        <p:nvSpPr>
-          <p:cNvPr id="22" name="text"/>
-          <p:cNvSpPr txBox="1"/>
-          <p:nvPr/>
-        </p:nvSpPr>
-        <p:spPr>
-          <a:xfrm>
-            <a:off x="7726680" y="4800600"/>
-            <a:ext cx="3733495" cy="914400"/>
-          </a:xfrm>
-          <a:prstGeom prst="rect">
-            <a:avLst/>
-          </a:prstGeom>
-          <a:noFill/>
-          <a:ln/>
-        </p:spPr>
-        <p:txBody>
-          <a:bodyPr wrap="square" lIns="0" tIns="0" rIns="0" bIns="0" rtlCol="0" anchor="t"/>
-          <a:lstStyle/>
-          <a:p>
-            <a:pPr algn="l" indent="0" marL="0">
-              <a:buNone/>
-            </a:pPr>
-            <a:r>
-              <a:rPr lang="en-US" sz="1200" dirty="0">
+              <a:rPr lang="en-US" sz="1150" dirty="0">
                 <a:solidFill>
                   <a:srgbClr val="5E5E5E"/>
                 </a:solidFill>
               </a:rPr>
-              <a:t>On 10,000-stay samples all neural models reach AUROC 0.80 to 0.81: the full cohort will separate them. The winner's method is being replicated on MIMIC-IV now.</a:t>
-            </a:r>
-            <a:endParaRPr lang="en-US" sz="1200" dirty="0"/>
-          </a:p>
-        </p:txBody>
-      </p:sp>
-      <p:sp>
-        <p:nvSpPr>
-          <p:cNvPr id="23" name="references"/>
+              <a:t>Rules fixed in advance, applied on validation: organ grouping did not beat the same model without it; GRU-D, TCN and flat OSTA shortlisted. Validation and test rankings disagree, so the full cohort decides.</a:t>
+            </a:r>
+            <a:endParaRPr lang="en-US" sz="1150" dirty="0"/>
+          </a:p>
+        </p:txBody>
+      </p:sp>
+      <p:sp>
+        <p:nvSpPr>
+          <p:cNvPr id="25" name="references"/>
           <p:cNvSpPr txBox="1"/>
           <p:nvPr/>
         </p:nvSpPr>
@@ -17504,7 +17582,7 @@
                 <a:ea typeface="Arial" pitchFamily="34" charset="-122"/>
                 <a:cs typeface="Arial" pitchFamily="34" charset="-120"/>
               </a:rPr>
-              <a:t>On 10,000 stays every model overfits within three epochs</a:t>
+              <a:t>On 10,000 stays models overfit fast and the validation split is too small to rank them</a:t>
             </a:r>
             <a:endParaRPr lang="en-US" sz="2400" dirty="0"/>
           </a:p>
@@ -17684,7 +17762,7 @@
                   <a:srgbClr val="C8102E"/>
                 </a:solidFill>
               </a:rPr>
-              <a:t>0.80 to 0.81</a:t>
+              <a:t>0.12 vs 0.28</a:t>
             </a:r>
             <a:endParaRPr lang="en-US" sz="3600" dirty="0"/>
           </a:p>
@@ -17720,7 +17798,7 @@
                   <a:srgbClr val="1B1B1B"/>
                 </a:solidFill>
               </a:rPr>
-              <a:t>AUROC of OSTA, CNN-Transformer, output fusion: differences below seed noise (SD 0.012)</a:t>
+              <a:t>validation utility of OSTA and flat OSTA, which tie on test (0.23): validation and test rankings disagree</a:t>
             </a:r>
             <a:endParaRPr lang="en-US" sz="1400" dirty="0"/>
           </a:p>

</xml_diff>

<commit_message>
Final code-audited study protocol; earlier disclosures; 659 predictors
PROTOCOL.md rewritten after a claim-by-claim audit against the code embedded in
the _11 notebook: exact label, cohort exclusions, hourly grid, holdout hash,
splits, availability and expiry rules, every predictor class, model
architectures and sizes, losses, both alarm thresholds, which metrics carry
bootstrap intervals, conformal and stress definitions, decision rules as
implemented, legacy notebook, development history, open TO FREEZE items.
PROTOCOL_DEVIATIONS.md adds disclosures E1-E4. Deck, RD6 report: 659 predictors.

Co-Authored-By: Claude Opus 5.5 <noreply@anthropic.com>
Claude-Session: https://claude.ai/code/session_01LgDqxV9dzSvE8XpquGaBd5
</commit_message>
<xml_diff>
--- a/dev/presentation/Elrggal_Mahmoud_SCEBE2026.pptx
+++ b/dev/presentation/Elrggal_Mahmoud_SCEBE2026.pptx
@@ -134,7 +134,7 @@
   <p:extLst>
     <p:ext uri="{521415D9-36F7-43E2-AB2F-B90AF26B5E84}">
       <p14:sectionLst xmlns:p14="http://schemas.microsoft.com/office/powerpoint/2010/main">
-        <p14:section name="Context" id="{65761b91-fd18-9147-f466-5be96fbf8367}">
+        <p14:section name="Context" id="{1bd875a1-9514-e5e1-068d-6a96299f9b55}">
           <p14:sldIdLst>
             <p14:sldId id="256"/>
             <p14:sldId id="257"/>
@@ -143,7 +143,7 @@
             <p14:sldId id="260"/>
           </p14:sldIdLst>
         </p14:section>
-        <p14:section name="Question and approach" id="{885e5baf-3d98-0595-fae8-6c77fe57e6b1}">
+        <p14:section name="Question and approach" id="{587ad090-13a0-b4e0-dea1-5ad1fda654a0}">
           <p14:sldIdLst>
             <p14:sldId id="261"/>
             <p14:sldId id="262"/>
@@ -152,24 +152,24 @@
             <p14:sldId id="265"/>
           </p14:sldIdLst>
         </p14:section>
-        <p14:section name="Preliminary results" id="{1efb7e9c-16d2-1a6e-97d2-fec677007659}">
+        <p14:section name="Preliminary results" id="{a521c475-c318-f49c-8ba1-39738fa92e94}">
           <p14:sldIdLst>
             <p14:sldId id="266"/>
             <p14:sldId id="267"/>
             <p14:sldId id="268"/>
           </p14:sldIdLst>
         </p14:section>
-        <p14:section name="Contribution and next steps" id="{d30e2750-ff7b-76a0-4a7b-bc9516c457fb}">
+        <p14:section name="Contribution and next steps" id="{026fd597-d914-bb0c-cf88-155c577a996f}">
           <p14:sldIdLst>
             <p14:sldId id="269"/>
           </p14:sldIdLst>
         </p14:section>
-        <p14:section name="Input" id="{7bb0c6c2-753b-10e6-dfa0-b98e1642e902}">
+        <p14:section name="Input" id="{4d04d5fa-b998-d075-37ed-8ea95c0d75f6}">
           <p14:sldIdLst>
             <p14:sldId id="270"/>
           </p14:sldIdLst>
         </p14:section>
-        <p14:section name="Backup" id="{03065c7a-640d-3cb2-8513-87ba0efd6609}">
+        <p14:section name="Backup" id="{34c9ebca-1a47-2550-08ca-cb1076509013}">
           <p14:sldIdLst>
             <p14:sldId id="271"/>
             <p14:sldId id="272"/>
@@ -10258,7 +10258,7 @@
                   <a:srgbClr val="5E5E5E"/>
                 </a:solidFill>
               </a:rPr>
-              <a:t>one sepsis definition, two hospital systems, 655 clinically defined predictors [41]</a:t>
+              <a:t>one sepsis definition, two hospital systems, 659 clinically defined predictors [41]</a:t>
             </a:r>
             <a:endParaRPr lang="en-US" sz="1250" dirty="0"/>
           </a:p>
@@ -13722,7 +13722,7 @@
                           <a:ea typeface="Arial" pitchFamily="34" charset="-122"/>
                           <a:cs typeface="Arial" pitchFamily="34" charset="-120"/>
                         </a:rPr>
-                        <a:t>655 clinically defined predictors</a:t>
+                        <a:t>659 clinically defined predictors</a:t>
                       </a:r>
                       <a:endParaRPr lang="en-US" sz="1150" dirty="0">
                         <a:latin typeface="Arial" charset="0"/>
@@ -14411,7 +14411,7 @@
                 <a:ea typeface="Arial" pitchFamily="34" charset="-122"/>
                 <a:cs typeface="Arial" pitchFamily="34" charset="-120"/>
               </a:rPr>
-              <a:t>The 655 predictors, each with a measured flag and an age</a:t>
+              <a:t>The 659 predictors, each with a measured flag and an age</a:t>
             </a:r>
             <a:endParaRPr lang="en-US" sz="2400" dirty="0"/>
           </a:p>
@@ -14993,7 +14993,7 @@
                   <a:srgbClr val="1B1B1B"/>
                 </a:solidFill>
               </a:rPr>
-              <a:t>admission source, ICU type, hours before ICU, prior admissions, prior positive cultures and antibiotics, 17 comorbidities, imaging orders</a:t>
+              <a:t>admission source, ICU type, hours before ICU, prior admissions, prior positive cultures and antibiotics (MIMIC-IV only), 17 comorbidities, imaging orders</a:t>
             </a:r>
             <a:endParaRPr lang="en-US" sz="1150" dirty="0"/>
           </a:p>
@@ -15187,7 +15187,7 @@
                   <a:srgbClr val="1B1B1B"/>
                 </a:solidFill>
               </a:rPr>
-              <a:t>label-defining antibiotics and cultures; race, ethnicity, insurance (fairness analysis only); anything after the prediction hour</a:t>
+              <a:t>label-defining antibiotics and cultures; race, ethnicity, insurance (reserved for a planned fairness analysis); anything after the prediction hour</a:t>
             </a:r>
             <a:endParaRPr lang="en-US" sz="1150" dirty="0"/>
           </a:p>
@@ -24708,7 +24708,7 @@
                   <a:srgbClr val="1B1B1B"/>
                 </a:solidFill>
               </a:rPr>
-              <a:t>septic stays per training split, against 300 to 655 predictors</a:t>
+              <a:t>septic stays per training split, against 300 to 659 predictors</a:t>
             </a:r>
             <a:endParaRPr lang="en-US" sz="1400" dirty="0"/>
           </a:p>
@@ -33989,7 +33989,7 @@
                   <a:srgbClr val="1B1B1B"/>
                 </a:solidFill>
               </a:rPr>
-              <a:t>655, each used only from the hour recorded</a:t>
+              <a:t>659, each used only from the hour recorded</a:t>
             </a:r>
             <a:endParaRPr lang="en-US" sz="1200" dirty="0"/>
           </a:p>

</xml_diff>

<commit_message>
Deck backups: state precisely that post-onset hours are never scored as warnings
Glossary and six-choices backups no longer say post-onset hours are unused,
which the V11 loss contradicts; values are used from the hour they became
available and most expire after 24 h.

Co-Authored-By: Claude Opus 5.5 <noreply@anthropic.com>
Claude-Session: https://claude.ai/code/session_01LgDqxV9dzSvE8XpquGaBd5
</commit_message>
<xml_diff>
--- a/dev/presentation/Elrggal_Mahmoud_SCEBE2026.pptx
+++ b/dev/presentation/Elrggal_Mahmoud_SCEBE2026.pptx
@@ -134,7 +134,7 @@
   <p:extLst>
     <p:ext uri="{521415D9-36F7-43E2-AB2F-B90AF26B5E84}">
       <p14:sectionLst xmlns:p14="http://schemas.microsoft.com/office/powerpoint/2010/main">
-        <p14:section name="Context" id="{1bd875a1-9514-e5e1-068d-6a96299f9b55}">
+        <p14:section name="Context" id="{f8dd6fdd-f602-555c-f906-47072626ef8c}">
           <p14:sldIdLst>
             <p14:sldId id="256"/>
             <p14:sldId id="257"/>
@@ -143,7 +143,7 @@
             <p14:sldId id="260"/>
           </p14:sldIdLst>
         </p14:section>
-        <p14:section name="Question and approach" id="{587ad090-13a0-b4e0-dea1-5ad1fda654a0}">
+        <p14:section name="Question and approach" id="{dd6136c1-290f-1bfd-2dbf-4f8bd4c94fe6}">
           <p14:sldIdLst>
             <p14:sldId id="261"/>
             <p14:sldId id="262"/>
@@ -152,24 +152,24 @@
             <p14:sldId id="265"/>
           </p14:sldIdLst>
         </p14:section>
-        <p14:section name="Preliminary results" id="{a521c475-c318-f49c-8ba1-39738fa92e94}">
+        <p14:section name="Preliminary results" id="{2e9374e6-6146-4b59-1a69-f2ba246897b2}">
           <p14:sldIdLst>
             <p14:sldId id="266"/>
             <p14:sldId id="267"/>
             <p14:sldId id="268"/>
           </p14:sldIdLst>
         </p14:section>
-        <p14:section name="Contribution and next steps" id="{026fd597-d914-bb0c-cf88-155c577a996f}">
+        <p14:section name="Contribution and next steps" id="{9bd5aae4-1ed4-ea22-8eda-a7c5004ffc2f}">
           <p14:sldIdLst>
             <p14:sldId id="269"/>
           </p14:sldIdLst>
         </p14:section>
-        <p14:section name="Input" id="{4d04d5fa-b998-d075-37ed-8ea95c0d75f6}">
+        <p14:section name="Input" id="{8435e38e-0b49-4499-5a8f-c4ede434f37b}">
           <p14:sldIdLst>
             <p14:sldId id="270"/>
           </p14:sldIdLst>
         </p14:section>
-        <p14:section name="Backup" id="{34c9ebca-1a47-2550-08ca-cb1076509013}">
+        <p14:section name="Backup" id="{1ab791be-e7ab-2bef-d7e1-6e72de1dc0b0}">
           <p14:sldIdLst>
             <p14:sldId id="271"/>
             <p14:sldId id="272"/>
@@ -12315,7 +12315,7 @@
                   <a:srgbClr val="1B1B1B"/>
                 </a:solidFill>
               </a:rPr>
-              <a:t>Each value used only from the hour it was recorded, with a measured flag and its age; no hour after onset used</a:t>
+              <a:t>Each value used only from the hour it became available, with a measured flag and its age; hours after onset are never scored as warnings</a:t>
             </a:r>
             <a:endParaRPr lang="en-US" sz="1200" dirty="0"/>
           </a:p>
@@ -13525,7 +13525,7 @@
                           <a:ea typeface="Arial" pitchFamily="34" charset="-122"/>
                           <a:cs typeface="Arial" pitchFamily="34" charset="-120"/>
                         </a:rPr>
-                        <a:t>Each value used from the hour recorded, expires after 24 h; post-onset hours excluded</a:t>
+                        <a:t>Each value used from the hour available, most expire after 24 h; hours after onset never scored as warnings</a:t>
                       </a:r>
                       <a:endParaRPr lang="en-US" sz="1150" dirty="0">
                         <a:latin typeface="Arial" charset="0"/>

</xml_diff>

<commit_message>
Winner comparison: 'winner's approach' not 'method'; state which bars are internal
The signature benchmark is the winner's approach (signature features on our
predictors with our boosted trees), not a replication of its pipeline. Slide 13,
the RD6 report and the protocol now say that our MIMIC-IV bars are the
counterpart of the winner's 0.43 (internal; PhysioNet hospital A is Beth Israel
Deaconess, the MIMIC-IV hospital) and that the counterpart of its -0.12 is the
sealed cross-database holdout, so PhysioNet is not an external test for a
MIMIC-IV-trained model.

Co-Authored-By: Claude Fable 5.1 <noreply@anthropic.com>
Claude-Session: https://claude.ai/code/session_01LgDqxV9dzSvE8XpquGaBd5
</commit_message>
<xml_diff>
--- a/dev/presentation/Elrggal_Mahmoud_SCEBE2026.pptx
+++ b/dev/presentation/Elrggal_Mahmoud_SCEBE2026.pptx
@@ -134,7 +134,7 @@
   <p:extLst>
     <p:ext uri="{521415D9-36F7-43E2-AB2F-B90AF26B5E84}">
       <p14:sectionLst xmlns:p14="http://schemas.microsoft.com/office/powerpoint/2010/main">
-        <p14:section name="Context" id="{f8dd6fdd-f602-555c-f906-47072626ef8c}">
+        <p14:section name="Context" id="{c3199a21-2e46-8609-d8ce-2f5e0a2507c7}">
           <p14:sldIdLst>
             <p14:sldId id="256"/>
             <p14:sldId id="257"/>
@@ -143,7 +143,7 @@
             <p14:sldId id="260"/>
           </p14:sldIdLst>
         </p14:section>
-        <p14:section name="Question and approach" id="{dd6136c1-290f-1bfd-2dbf-4f8bd4c94fe6}">
+        <p14:section name="Question and approach" id="{9801c369-ee3e-8979-6984-ed3332f21d8e}">
           <p14:sldIdLst>
             <p14:sldId id="261"/>
             <p14:sldId id="262"/>
@@ -152,24 +152,24 @@
             <p14:sldId id="265"/>
           </p14:sldIdLst>
         </p14:section>
-        <p14:section name="Preliminary results" id="{2e9374e6-6146-4b59-1a69-f2ba246897b2}">
+        <p14:section name="Preliminary results" id="{576fe539-98bc-d1df-6206-8e06c9c77ab7}">
           <p14:sldIdLst>
             <p14:sldId id="266"/>
             <p14:sldId id="267"/>
             <p14:sldId id="268"/>
           </p14:sldIdLst>
         </p14:section>
-        <p14:section name="Contribution and next steps" id="{9bd5aae4-1ed4-ea22-8eda-a7c5004ffc2f}">
+        <p14:section name="Contribution and next steps" id="{3174f4de-803b-8bd4-d28c-19bddc9011e0}">
           <p14:sldIdLst>
             <p14:sldId id="269"/>
           </p14:sldIdLst>
         </p14:section>
-        <p14:section name="Input" id="{8435e38e-0b49-4499-5a8f-c4ede434f37b}">
+        <p14:section name="Input" id="{7017ff5d-df12-34e9-91d6-fc8812e0e4b5}">
           <p14:sldIdLst>
             <p14:sldId id="270"/>
           </p14:sldIdLst>
         </p14:section>
-        <p14:section name="Backup" id="{1ab791be-e7ab-2bef-d7e1-6e72de1dc0b0}">
+        <p14:section name="Backup" id="{7e410d07-857b-74c9-5055-fab9545392ae}">
           <p14:sldIdLst>
             <p14:sldId id="271"/>
             <p14:sldId id="272"/>
@@ -760,7 +760,7 @@
                     <c:v>Winner, published: unseen hospital</c:v>
                   </c:pt>
                   <c:pt idx="2">
-                    <c:v>Winner's method, rebuilt here</c:v>
+                    <c:v>Winner's approach, rebuilt here</c:v>
                   </c:pt>
                   <c:pt idx="3">
                     <c:v>OSTA (this project)</c:v>
@@ -2198,7 +2198,7 @@
           <a:p>
             <a:r>
               <a:rPr lang="en-US" dirty="0"/>
-              <a:t>1 min. Grey is the published winner: 0.43 on its own hospitals, minus 0.12 on an unseen one. Dark grey is the winner's own method rebuilt in our causal pipeline on MIMIC-IV: 0.15. Red is this project: OSTA 0.23, and GRU-D, the model the prespecified rule chose on validation, 0.19. All 21 models have positive utility with confidence intervals above zero. The organ grouping did not beat the same model without it at this sample size; that is reported as found. Say: preliminary, one run, development split.</a:t>
+              <a:t>1 min. Grey is the published winner: 0.43 on its own hospitals, minus 0.12 on an unseen one. Dark grey is the winner's approach, path signatures plus boosted trees, rebuilt in our causal pipeline on all our predictors: 0.15. Say clearly: our bars are the counterpart of the 0.43, an internal split, and the same hospital system, because PhysioNet hospital A is Beth Israel Deaconess, the MIMIC-IV hospital. The counterpart of minus 0.12 is the sealed cross-database holdout, not yet opened. Red is this project: OSTA 0.23, and GRU-D, the model the prespecified rule chose on validation, 0.19. All 21 models have positive utility with confidence intervals above zero. The organ grouping did not beat the same model without it at this sample size; that is reported as found. Say: preliminary, one run, development split.</a:t>
             </a:r>
             <a:endParaRPr lang="en-US" dirty="0"/>
           </a:p>
@@ -7246,7 +7246,7 @@
                   <a:srgbClr val="5E5E5E"/>
                 </a:solidFill>
               </a:rPr>
-              <a:t>the PhysioNet 2019 winner's method [21]</a:t>
+              <a:t>the PhysioNet 2019 winner's approach [21]</a:t>
             </a:r>
             <a:endParaRPr lang="en-US" sz="1200" dirty="0"/>
           </a:p>
@@ -9298,7 +9298,7 @@
                 <a:ea typeface="Arial" pitchFamily="34" charset="-122"/>
                 <a:cs typeface="Arial" pitchFamily="34" charset="-120"/>
               </a:rPr>
-              <a:t>Result 3: on identical MIMIC-IV hours, all 21 models have positive utility, including the winner's method</a:t>
+              <a:t>Result 3: on identical MIMIC-IV hours, all 21 models have positive utility, including the winner's approach</a:t>
             </a:r>
             <a:endParaRPr lang="en-US" sz="2600" dirty="0"/>
           </a:p>
@@ -9436,7 +9436,7 @@
                   <a:srgbClr val="1B1B1B"/>
                 </a:solidFill>
               </a:rPr>
-              <a:t>Winner's method, our pipeline</a:t>
+              <a:t>Winner's approach, our pipeline</a:t>
             </a:r>
             <a:endParaRPr lang="en-US" sz="1200" dirty="0"/>
           </a:p>
@@ -9505,7 +9505,43 @@
       </p:sp>
       <p:sp>
         <p:nvSpPr>
-          <p:cNvPr id="13" name="box"/>
+          <p:cNvPr id="13" name="text"/>
+          <p:cNvSpPr txBox="1"/>
+          <p:nvPr/>
+        </p:nvSpPr>
+        <p:spPr>
+          <a:xfrm>
+            <a:off x="548640" y="5760720"/>
+            <a:ext cx="6858000" cy="365760"/>
+          </a:xfrm>
+          <a:prstGeom prst="rect">
+            <a:avLst/>
+          </a:prstGeom>
+          <a:noFill/>
+          <a:ln/>
+        </p:spPr>
+        <p:txBody>
+          <a:bodyPr wrap="square" lIns="0" tIns="0" rIns="0" bIns="0" rtlCol="0" anchor="t"/>
+          <a:lstStyle/>
+          <a:p>
+            <a:pPr algn="l" indent="0" marL="0">
+              <a:buNone/>
+            </a:pPr>
+            <a:r>
+              <a:rPr lang="en-US" sz="1000" dirty="0">
+                <a:solidFill>
+                  <a:srgbClr val="5E5E5E"/>
+                </a:solidFill>
+              </a:rPr>
+              <a:t>Counterpart of the winner's 0.43, not of -0.12: an internal split, and the same hospital system (PhysioNet hospital A is Beth Israel Deaconess, the MIMIC-IV hospital) [15]. The transfer test is the sealed holdout, still closed.</a:t>
+            </a:r>
+            <a:endParaRPr lang="en-US" sz="1000" dirty="0"/>
+          </a:p>
+        </p:txBody>
+      </p:sp>
+      <p:sp>
+        <p:nvSpPr>
+          <p:cNvPr id="14" name="box"/>
           <p:cNvSpPr/>
           <p:nvPr/>
         </p:nvSpPr>
@@ -9530,7 +9566,7 @@
       </p:sp>
       <p:sp>
         <p:nvSpPr>
-          <p:cNvPr id="14" name="text"/>
+          <p:cNvPr id="15" name="text"/>
           <p:cNvSpPr txBox="1"/>
           <p:nvPr/>
         </p:nvSpPr>
@@ -9566,7 +9602,7 @@
       </p:sp>
       <p:sp>
         <p:nvSpPr>
-          <p:cNvPr id="15" name="text"/>
+          <p:cNvPr id="16" name="text"/>
           <p:cNvSpPr txBox="1"/>
           <p:nvPr/>
         </p:nvSpPr>
@@ -9602,7 +9638,7 @@
       </p:sp>
       <p:sp>
         <p:nvSpPr>
-          <p:cNvPr id="16" name="text"/>
+          <p:cNvPr id="17" name="text"/>
           <p:cNvSpPr txBox="1"/>
           <p:nvPr/>
         </p:nvSpPr>
@@ -9638,7 +9674,7 @@
       </p:sp>
       <p:sp>
         <p:nvSpPr>
-          <p:cNvPr id="17" name="text"/>
+          <p:cNvPr id="18" name="text"/>
           <p:cNvSpPr txBox="1"/>
           <p:nvPr/>
         </p:nvSpPr>
@@ -9674,7 +9710,7 @@
       </p:sp>
       <p:sp>
         <p:nvSpPr>
-          <p:cNvPr id="18" name="text"/>
+          <p:cNvPr id="19" name="text"/>
           <p:cNvSpPr txBox="1"/>
           <p:nvPr/>
         </p:nvSpPr>
@@ -9710,7 +9746,7 @@
       </p:sp>
       <p:sp>
         <p:nvSpPr>
-          <p:cNvPr id="19" name="text"/>
+          <p:cNvPr id="20" name="text"/>
           <p:cNvSpPr txBox="1"/>
           <p:nvPr/>
         </p:nvSpPr>
@@ -9746,7 +9782,7 @@
       </p:sp>
       <p:sp>
         <p:nvSpPr>
-          <p:cNvPr id="20" name="text"/>
+          <p:cNvPr id="21" name="text"/>
           <p:cNvSpPr txBox="1"/>
           <p:nvPr/>
         </p:nvSpPr>
@@ -9782,7 +9818,7 @@
       </p:sp>
       <p:sp>
         <p:nvSpPr>
-          <p:cNvPr id="21" name="text"/>
+          <p:cNvPr id="22" name="text"/>
           <p:cNvSpPr txBox="1"/>
           <p:nvPr/>
         </p:nvSpPr>
@@ -9818,7 +9854,7 @@
       </p:sp>
       <p:sp>
         <p:nvSpPr>
-          <p:cNvPr id="22" name="text"/>
+          <p:cNvPr id="23" name="text"/>
           <p:cNvSpPr txBox="1"/>
           <p:nvPr/>
         </p:nvSpPr>
@@ -9854,7 +9890,7 @@
       </p:sp>
       <p:sp>
         <p:nvSpPr>
-          <p:cNvPr id="23" name="text"/>
+          <p:cNvPr id="24" name="text"/>
           <p:cNvSpPr txBox="1"/>
           <p:nvPr/>
         </p:nvSpPr>
@@ -9882,7 +9918,7 @@
                   <a:srgbClr val="1B1B1B"/>
                 </a:solidFill>
               </a:rPr>
-              <a:t>winner's method, 95 % CI 0.06 to 0.22</a:t>
+              <a:t>winner's approach, 95 % CI 0.06 to 0.22</a:t>
             </a:r>
             <a:endParaRPr lang="en-US" sz="1150" dirty="0"/>
           </a:p>
@@ -9890,7 +9926,7 @@
       </p:sp>
       <p:sp>
         <p:nvSpPr>
-          <p:cNvPr id="24" name="text"/>
+          <p:cNvPr id="25" name="text"/>
           <p:cNvSpPr txBox="1"/>
           <p:nvPr/>
         </p:nvSpPr>
@@ -9926,7 +9962,7 @@
       </p:sp>
       <p:sp>
         <p:nvSpPr>
-          <p:cNvPr id="25" name="references"/>
+          <p:cNvPr id="26" name="references"/>
           <p:cNvSpPr txBox="1"/>
           <p:nvPr/>
         </p:nvSpPr>
@@ -17675,7 +17711,7 @@
                   <a:srgbClr val="1B1B1B"/>
                 </a:solidFill>
               </a:rPr>
-              <a:t>GRU-D, temporal CNN, the winner's method [37, 38, 21]</a:t>
+              <a:t>GRU-D, temporal CNN, the winner's approach [37, 38, 21]</a:t>
             </a:r>
             <a:endParaRPr lang="en-US" sz="1150" dirty="0"/>
           </a:p>
@@ -18016,7 +18052,7 @@
                 <a:ea typeface="Arial" pitchFamily="34" charset="-122"/>
                 <a:cs typeface="Arial" pitchFamily="34" charset="-120"/>
               </a:rPr>
-              <a:t>Every model compared (1 of 2): baselines, the winner's method and sequence models</a:t>
+              <a:t>Every model compared (1 of 2): baselines, the winner's approach and sequence models</a:t>
             </a:r>
             <a:endParaRPr lang="en-US" sz="2400" dirty="0"/>
           </a:p>
@@ -18996,7 +19032,7 @@
                           <a:ea typeface="Arial" pitchFamily="34" charset="-122"/>
                           <a:cs typeface="Arial" pitchFamily="34" charset="-120"/>
                         </a:rPr>
-                        <a:t>The PhysioNet 2019 winner's method; time enters through fixed summaries</a:t>
+                        <a:t>The PhysioNet 2019 winner's approach, not its full pipeline; time enters through fixed summaries</a:t>
                       </a:r>
                       <a:endParaRPr lang="en-US" sz="1250" dirty="0">
                         <a:latin typeface="Arial" charset="0"/>

</xml_diff>

<commit_message>
Results slides: remove published winner bars; claim only what the data support
Slide 13 now shows 8 of the 21 models scored on identical MIMIC-IV hours
(baselines, the winner's approach, this project's models) with no published
external numbers, titled 'all 21 models score above zero; none is shown to be
best'. Slide 12 no longer calls the leak 'the biggest single correction' or
reads utility 0.22 as a clinical benefit; post-onset hours are described as
scored-as-warnings rather than 'labelled positive'. RD6 and the protocol
soften the same claims; a paired per-stay utility comparison is recorded as a
planned analysis.

Co-Authored-By: Claude Fable 5.1 <noreply@anthropic.com>
Claude-Session: https://claude.ai/code/session_01LgDqxV9dzSvE8XpquGaBd5
</commit_message>
<xml_diff>
--- a/dev/presentation/Elrggal_Mahmoud_SCEBE2026.pptx
+++ b/dev/presentation/Elrggal_Mahmoud_SCEBE2026.pptx
@@ -134,7 +134,7 @@
   <p:extLst>
     <p:ext uri="{521415D9-36F7-43E2-AB2F-B90AF26B5E84}">
       <p14:sectionLst xmlns:p14="http://schemas.microsoft.com/office/powerpoint/2010/main">
-        <p14:section name="Context" id="{c3199a21-2e46-8609-d8ce-2f5e0a2507c7}">
+        <p14:section name="Context" id="{c41f36e5-d2ef-87f7-d5cd-73aa297bfcd9}">
           <p14:sldIdLst>
             <p14:sldId id="256"/>
             <p14:sldId id="257"/>
@@ -143,7 +143,7 @@
             <p14:sldId id="260"/>
           </p14:sldIdLst>
         </p14:section>
-        <p14:section name="Question and approach" id="{9801c369-ee3e-8979-6984-ed3332f21d8e}">
+        <p14:section name="Question and approach" id="{dec547d7-01ec-539d-65c9-e9f325e61cae}">
           <p14:sldIdLst>
             <p14:sldId id="261"/>
             <p14:sldId id="262"/>
@@ -152,24 +152,24 @@
             <p14:sldId id="265"/>
           </p14:sldIdLst>
         </p14:section>
-        <p14:section name="Preliminary results" id="{576fe539-98bc-d1df-6206-8e06c9c77ab7}">
+        <p14:section name="Preliminary results" id="{d56433d4-3b02-e333-5951-dc2bcd3f7140}">
           <p14:sldIdLst>
             <p14:sldId id="266"/>
             <p14:sldId id="267"/>
             <p14:sldId id="268"/>
           </p14:sldIdLst>
         </p14:section>
-        <p14:section name="Contribution and next steps" id="{3174f4de-803b-8bd4-d28c-19bddc9011e0}">
+        <p14:section name="Contribution and next steps" id="{ca19e670-c072-ac69-1a15-4d1dc99b9976}">
           <p14:sldIdLst>
             <p14:sldId id="269"/>
           </p14:sldIdLst>
         </p14:section>
-        <p14:section name="Input" id="{7017ff5d-df12-34e9-91d6-fc8812e0e4b5}">
+        <p14:section name="Input" id="{9bc603d9-9daf-f5ad-232c-a5dff5e706ab}">
           <p14:sldIdLst>
             <p14:sldId id="270"/>
           </p14:sldIdLst>
         </p14:section>
-        <p14:section name="Backup" id="{7e410d07-857b-74c9-5055-fab9545392ae}">
+        <p14:section name="Backup" id="{91e58c41-6b17-37bc-b450-3ad6ce943ece}">
           <p14:sldIdLst>
             <p14:sldId id="271"/>
             <p14:sldId id="272"/>
@@ -632,7 +632,7 @@
                 </a:solidFill>
                 <a:latin typeface="+mn-lt"/>
               </a:rPr>
-              <a:t>Normalised utility: 1 = perfect, 0 = never alarming, below 0 = worse than silence</a:t>
+              <a:t>Normalised utility on identical hours: 1 = perfect, 0 = never alarming (8 of 21 models shown)</a:t>
             </a:r>
           </a:p>
         </c:rich>
@@ -747,26 +747,68 @@
               <a:effectLst/>
             </c:spPr>
           </c:dPt>
+          <c:dPt>
+            <c:idx val="5"/>
+            <c:invertIfNegative val="0"/>
+            <c:bubble3D val="0"/>
+            <c:spPr>
+              <a:solidFill>
+                <a:srgbClr val="C8102E"/>
+              </a:solidFill>
+              <a:effectLst/>
+            </c:spPr>
+          </c:dPt>
+          <c:dPt>
+            <c:idx val="6"/>
+            <c:invertIfNegative val="0"/>
+            <c:bubble3D val="0"/>
+            <c:spPr>
+              <a:solidFill>
+                <a:srgbClr val="C8102E"/>
+              </a:solidFill>
+              <a:effectLst/>
+            </c:spPr>
+          </c:dPt>
+          <c:dPt>
+            <c:idx val="7"/>
+            <c:invertIfNegative val="0"/>
+            <c:bubble3D val="0"/>
+            <c:spPr>
+              <a:solidFill>
+                <a:srgbClr val="C8102E"/>
+              </a:solidFill>
+              <a:effectLst/>
+            </c:spPr>
+          </c:dPt>
           <c:cat>
             <c:multiLvlStrRef>
-              <c:f>Sheet1!$A$2:$A$6</c:f>
+              <c:f>Sheet1!$A$2:$A$9</c:f>
               <c:multiLvlStrCache>
-                <c:ptCount val="5"/>
+                <c:ptCount val="8"/>
                 <c:lvl>
                   <c:pt idx="0">
-                    <c:v>Winner, published: its 2 hospitals</c:v>
+                    <c:v>Logistic regression</c:v>
                   </c:pt>
                   <c:pt idx="1">
-                    <c:v>Winner, published: unseen hospital</c:v>
+                    <c:v>Boosted trees</c:v>
                   </c:pt>
                   <c:pt idx="2">
                     <c:v>Winner's approach, rebuilt here</c:v>
                   </c:pt>
                   <c:pt idx="3">
-                    <c:v>OSTA (this project)</c:v>
+                    <c:v>Temporal CNN</c:v>
                   </c:pt>
                   <c:pt idx="4">
                     <c:v>GRU-D (chosen on validation)</c:v>
+                  </c:pt>
+                  <c:pt idx="5">
+                    <c:v>Flat OSTA (no organ grouping)</c:v>
+                  </c:pt>
+                  <c:pt idx="6">
+                    <c:v>OSTA</c:v>
+                  </c:pt>
+                  <c:pt idx="7">
+                    <c:v>Self-supervised CNN to OSTA</c:v>
                   </c:pt>
                 </c:lvl>
               </c:multiLvlStrCache>
@@ -774,24 +816,33 @@
           </c:cat>
           <c:val>
             <c:numRef>
-              <c:f>Sheet1!$B$2:$B$6</c:f>
+              <c:f>Sheet1!$B$2:$B$9</c:f>
               <c:numCache>
                 <c:formatCode>General</c:formatCode>
-                <c:ptCount val="5"/>
+                <c:ptCount val="8"/>
                 <c:pt idx="0">
-                  <c:v>0.43</c:v>
+                  <c:v>0.08</c:v>
                 </c:pt>
                 <c:pt idx="1">
-                  <c:v>-0.12</c:v>
+                  <c:v>0.1</c:v>
                 </c:pt>
                 <c:pt idx="2">
                   <c:v>0.15</c:v>
                 </c:pt>
                 <c:pt idx="3">
-                  <c:v>0.23</c:v>
+                  <c:v>0.17</c:v>
                 </c:pt>
                 <c:pt idx="4">
                   <c:v>0.19</c:v>
+                </c:pt>
+                <c:pt idx="5">
+                  <c:v>0.23</c:v>
+                </c:pt>
+                <c:pt idx="6">
+                  <c:v>0.23</c:v>
+                </c:pt>
+                <c:pt idx="7">
+                  <c:v>0.29</c:v>
                 </c:pt>
               </c:numCache>
             </c:numRef>
@@ -852,7 +903,7 @@
           <a:lstStyle/>
           <a:p>
             <a:pPr>
-              <a:defRPr sz="1200" b="0" i="0" u="none" strike="noStrike">
+              <a:defRPr sz="1150" b="0" i="0" u="none" strike="noStrike">
                 <a:solidFill>
                   <a:srgbClr val="1B1B1B"/>
                 </a:solidFill>
@@ -872,8 +923,8 @@
         <c:axId val="2094734552"/>
         <c:scaling>
           <c:orientation val="minMax"/>
-          <c:max val="0.6"/>
-          <c:min val="-0.4"/>
+          <c:max val="0.4"/>
+          <c:min val="0"/>
         </c:scaling>
         <c:delete val="0"/>
         <c:axPos val="b"/>
@@ -919,7 +970,7 @@
         <c:crossAx val="2094734554"/>
         <c:crosses val="autoZero"/>
         <c:crossBetween val="between"/>
-        <c:majorUnit val="0.2"/>
+        <c:majorUnit val="0.1"/>
       </c:valAx>
       <c:spPr>
         <a:noFill/>
@@ -2198,7 +2249,7 @@
           <a:p>
             <a:r>
               <a:rPr lang="en-US" dirty="0"/>
-              <a:t>1 min. Grey is the published winner: 0.43 on its own hospitals, minus 0.12 on an unseen one. Dark grey is the winner's approach, path signatures plus boosted trees, rebuilt in our causal pipeline on all our predictors: 0.15. Say clearly: our bars are the counterpart of the 0.43, an internal split, and the same hospital system, because PhysioNet hospital A is Beth Israel Deaconess, the MIMIC-IV hospital. The counterpart of minus 0.12 is the sealed cross-database holdout, not yet opened. Red is this project: OSTA 0.23, and GRU-D, the model the prespecified rule chose on validation, 0.19. All 21 models have positive utility with confidence intervals above zero. The organ grouping did not beat the same model without it at this sample size; that is reported as found. Say: preliminary, one run, development split.</a:t>
+              <a:t>1 min. Eight of the 21 models, all scored on identical hours. Grey: the two baselines, 0.08 and 0.10. Dark grey: the winner's approach, signatures plus boosted trees, in our causal pipeline on all our predictors, 0.15. Red: this project, 0.17 to 0.29. Every one of the 21 is above zero with its interval above zero, under the challenge's scoring rules. Do not call any model best: the differences are within what 71 events can resolve, and paired comparisons on utility have not been run yet. Organ grouping was not supported on validation; the rule shortlisted GRU-D, TCN and flat OSTA. Internal split only: transfer is untested here and the holdout is closed.</a:t>
             </a:r>
             <a:endParaRPr lang="en-US" dirty="0"/>
           </a:p>
@@ -8411,7 +8462,7 @@
                 <a:ea typeface="Arial" pitchFamily="34" charset="-122"/>
                 <a:cs typeface="Arial" pitchFamily="34" charset="-120"/>
               </a:rPr>
-              <a:t>Result 2: removing information from the future is the biggest single correction</a:t>
+              <a:t>Result 2: removing information from the future, and the honest baseline it leaves</a:t>
             </a:r>
             <a:endParaRPr lang="en-US" sz="2600" dirty="0"/>
           </a:p>
@@ -8561,7 +8612,7 @@
                   <a:srgbClr val="1B1B1B"/>
                 </a:solidFill>
               </a:rPr>
-              <a:t>Hours after sepsis onset labelled positive: the model learnt sepsis that had already started.</a:t>
+              <a:t>Hours after onset scored as correct early warnings: recognising sepsis already present counted as predicting it.</a:t>
             </a:r>
             <a:endParaRPr lang="en-US" sz="1400" dirty="0"/>
           </a:p>
@@ -9036,7 +9087,7 @@
                   <a:srgbClr val="1B1B1B"/>
                 </a:solidFill>
               </a:rPr>
-              <a:t>Utility 0.22: the alarms are worth about a fifth of perfect alarms after paying for false alarms.</a:t>
+              <a:t>Utility 0.22: about a fifth of the way from never alarming to perfect alarms, under the challenge's scoring rules; a score, not a measured clinical benefit.</a:t>
             </a:r>
             <a:endParaRPr lang="en-US" sz="1350" dirty="0"/>
           </a:p>
@@ -9298,7 +9349,7 @@
                 <a:ea typeface="Arial" pitchFamily="34" charset="-122"/>
                 <a:cs typeface="Arial" pitchFamily="34" charset="-120"/>
               </a:rPr>
-              <a:t>Result 3: on identical MIMIC-IV hours, all 21 models have positive utility, including the winner's approach</a:t>
+              <a:t>Result 3: on identical MIMIC-IV hours, all 21 models score above zero; none is shown to be best</a:t>
             </a:r>
             <a:endParaRPr lang="en-US" sz="2600" dirty="0"/>
           </a:p>
@@ -9375,7 +9426,7 @@
                   <a:srgbClr val="1B1B1B"/>
                 </a:solidFill>
               </a:rPr>
-              <a:t>Published [15, 21]</a:t>
+              <a:t>Baselines</a:t>
             </a:r>
             <a:endParaRPr lang="en-US" sz="1200" dirty="0"/>
           </a:p>
@@ -9436,7 +9487,7 @@
                   <a:srgbClr val="1B1B1B"/>
                 </a:solidFill>
               </a:rPr>
-              <a:t>Winner's approach, our pipeline</a:t>
+              <a:t>Winner's approach [21]</a:t>
             </a:r>
             <a:endParaRPr lang="en-US" sz="1200" dirty="0"/>
           </a:p>
@@ -9533,7 +9584,7 @@
                   <a:srgbClr val="5E5E5E"/>
                 </a:solidFill>
               </a:rPr>
-              <a:t>Counterpart of the winner's 0.43, not of -0.12: an internal split, and the same hospital system (PhysioNet hospital A is Beth Israel Deaconess, the MIMIC-IV hospital) [15]. The transfer test is the sealed holdout, still closed.</a:t>
+              <a:t>Internal MIMIC-IV test split. No model is shown to be better than another: the differences are within what 71 events can resolve. Transfer to another hospital system is untested here; the sealed holdout is still closed.</a:t>
             </a:r>
             <a:endParaRPr lang="en-US" sz="1000" dirty="0"/>
           </a:p>
@@ -9954,7 +10005,7 @@
                   <a:srgbClr val="5E5E5E"/>
                 </a:solidFill>
               </a:rPr>
-              <a:t>Rules fixed in advance, applied on validation: organ grouping did not beat the same model without it; GRU-D, TCN and flat OSTA shortlisted. Validation and test rankings disagree, so the full cohort decides.</a:t>
+              <a:t>Rules fixed in advance, applied on validation: organ grouping did not beat the same model without it; GRU-D, TCN and flat OSTA shortlisted. Validation and test rankings disagree; the full cohort will narrow the uncertainty.</a:t>
             </a:r>
             <a:endParaRPr lang="en-US" sz="1150" dirty="0"/>
           </a:p>
@@ -9990,7 +10041,7 @@
                   <a:srgbClr val="5E5E5E"/>
                 </a:solidFill>
               </a:rPr>
-              <a:t>[15] Reyna et al., Crit Care Med 2020   [21] Morrill et al., Crit Care Med 2020   [41] This work, preliminary, unpublished</a:t>
+              <a:t>[21] Morrill et al., Crit Care Med 2020   [41] This work, preliminary, unpublished</a:t>
             </a:r>
             <a:endParaRPr lang="en-US" sz="950" dirty="0"/>
           </a:p>
@@ -24363,7 +24414,7 @@
                   <a:srgbClr val="1B1B1B"/>
                 </a:solidFill>
               </a:rPr>
-              <a:t>Labels: Sepsis-3 via YAIB / ricu [33, 34]; onset within the next 6 h; post-onset hours excluded; up to 120 h per stay.</a:t>
+              <a:t>Labels: Sepsis-3 via YAIB / ricu [33, 34]; onset within the next 6 h; hours after onset never scored as warnings; up to 120 h per stay.</a:t>
             </a:r>
             <a:endParaRPr lang="en-US" sz="1400" dirty="0"/>
           </a:p>

</xml_diff>

<commit_message>
Fold the completed eICU arm of run 4cd752bef2ccbd42 into the deck, RD6 report, protocol and script
- dev/results: aggregate notebook outputs and a results digest for the run
- Deck: slide 13 right panel with per-model MIMIC-IV-to-eICU bars and the
  eICU-at-home band; slides 14, 15 and backup 23 updated
- RD6: two-database results table, eICU paragraph, rule outcomes, cohort counts
- PROTOCOL.md: stage-1 outcome on eICU and the cross-database reading of the
  rules; PROTOCOL_DEVIATIONS.md: D1 addendum; Word copies regenerated
- Rehearsal script re-exported (Word and PDF); handover and change log updated

Co-Authored-By: Claude Fable 5.1 <noreply@anthropic.com>
Claude-Session: https://claude.ai/code/session_01LgDqxV9dzSvE8XpquGaBd5
</commit_message>
<xml_diff>
--- a/dev/presentation/Elrggal_Mahmoud_SCEBE2026.pptx
+++ b/dev/presentation/Elrggal_Mahmoud_SCEBE2026.pptx
@@ -136,7 +136,7 @@
   <p:extLst>
     <p:ext uri="{521415D9-36F7-43E2-AB2F-B90AF26B5E84}">
       <p14:sectionLst xmlns:p14="http://schemas.microsoft.com/office/powerpoint/2010/main">
-        <p14:section name="Context" id="{8e09e19a-7ac4-187b-faab-f00c6243c650}">
+        <p14:section name="Context" id="{3b03f11f-ca15-610c-d5de-086c05a4a83c}">
           <p14:sldIdLst>
             <p14:sldId id="256"/>
             <p14:sldId id="257"/>
@@ -145,7 +145,7 @@
             <p14:sldId id="260"/>
           </p14:sldIdLst>
         </p14:section>
-        <p14:section name="Question and approach" id="{62371bae-b35a-0aee-de8b-d9180943dfc5}">
+        <p14:section name="Question and approach" id="{e02448e3-6c19-5f6d-66ef-b766d1a61505}">
           <p14:sldIdLst>
             <p14:sldId id="261"/>
             <p14:sldId id="262"/>
@@ -154,28 +154,28 @@
             <p14:sldId id="265"/>
           </p14:sldIdLst>
         </p14:section>
-        <p14:section name="Results" id="{896bec22-fbc0-5ae7-4d0e-006d2c8dbbdf}">
+        <p14:section name="Results" id="{66456693-9539-68af-01d6-610ea632acad}">
           <p14:sldIdLst>
             <p14:sldId id="266"/>
           </p14:sldIdLst>
         </p14:section>
-        <p14:section name="Preliminary results" id="{ef19e13d-ecd0-d329-e69b-ab2d8555b664}">
+        <p14:section name="Preliminary results" id="{a85622f1-2db9-85fb-a6d9-2ee5e3ccc535}">
           <p14:sldIdLst>
             <p14:sldId id="267"/>
             <p14:sldId id="268"/>
           </p14:sldIdLst>
         </p14:section>
-        <p14:section name="Contribution and next steps" id="{bd5a7cf2-fee2-d859-06e1-490e0b56d80a}">
+        <p14:section name="Contribution and next steps" id="{12350115-7e16-5055-9531-ecfc6a752440}">
           <p14:sldIdLst>
             <p14:sldId id="269"/>
           </p14:sldIdLst>
         </p14:section>
-        <p14:section name="Take-home" id="{85ce6b96-7b24-ca47-d504-2590f3a5dd26}">
+        <p14:section name="Take-home" id="{b197065e-d0b8-bc29-92f2-12610beb7807}">
           <p14:sldIdLst>
             <p14:sldId id="270"/>
           </p14:sldIdLst>
         </p14:section>
-        <p14:section name="Backup" id="{d05c25ce-81dd-788d-86ba-5531e665e40e}">
+        <p14:section name="Backup" id="{bbbce2e8-9ebd-f761-3886-f529c8f7f93a}">
           <p14:sldIdLst>
             <p14:sldId id="271"/>
             <p14:sldId id="272"/>
@@ -2245,7 +2245,7 @@
           <a:p>
             <a:r>
               <a:rPr lang="en-US" dirty="0"/>
-              <a:t>1 min. Left, own hospital system: the winner at 0.36 official (0.43 on its own hospitals) and this project on MIMIC-IV, 0.08 to 0.29, all above zero, none shown best. Right, unseen hospital system: the winner at minus 0.12; this project, MIMIC-IV models on eICU patients, about zero with intervals including zero. Say it plainly: at home every model keeps a positive utility; away, we are not below silence but not above it either, and the sealed holdout decides. Organ grouping not supported on validation; rule-chosen shortlist GRU-D, TCN, flat OSTA.</a:t>
+              <a:t>1 min. Left, own hospital system: the winner at 0.36 official (0.43 on its own hospitals) and this project on MIMIC-IV, 0.08 to 0.29, all above zero, none shown best. Right, unseen hospital system: the winner at minus 0.12; this project, the same eight models trained on MIMIC-IV and scored on eICU patients, minus 0.15 (logistic) to plus 0.04, about zero. The pink band is eICU's own models trained on eICU itself: 0.00 to 0.08 on the same 45 events. Say it plainly: at home on MIMIC-IV every model keeps a positive utility; on eICU, away and at home coincide near zero, so the problem there is the sample and the label as much as transfer, and the full cohort and the sealed holdout decide. Organ grouping not supported on either database; shortlists GRU-D, TCN, flat OSTA (MIMIC-IV) and GRU-D, flat OSTA, pooled self-supervised flat CNN (eICU).</a:t>
             </a:r>
             <a:endParaRPr lang="en-US" dirty="0"/>
           </a:p>
@@ -13350,7 +13350,7 @@
                   <a:srgbClr val="5E5E5E"/>
                 </a:solidFill>
               </a:rPr>
-              <a:t>the winner on a hidden third hospital; this project: MIMIC-IV models scored on eICU patients, development level</a:t>
+              <a:t>the winner on a hidden third hospital; this project: MIMIC-IV models scored on eICU patients (888 stays, 45 events), development level</a:t>
             </a:r>
             <a:endParaRPr lang="en-US" sz="1000" dirty="0"/>
           </a:p>
@@ -13364,8 +13364,8 @@
         </p:nvSpPr>
         <p:spPr>
           <a:xfrm>
-            <a:off x="9052560" y="4572000"/>
-            <a:ext cx="2361895" cy="914"/>
+            <a:off x="9098280" y="5029200"/>
+            <a:ext cx="2316175" cy="914"/>
           </a:xfrm>
           <a:prstGeom prst="line">
             <a:avLst/>
@@ -13387,7 +13387,7 @@
         </p:nvSpPr>
         <p:spPr>
           <a:xfrm>
-            <a:off x="9052560" y="4572000"/>
+            <a:off x="9098280" y="5029200"/>
             <a:ext cx="914" cy="73152"/>
           </a:xfrm>
           <a:prstGeom prst="line">
@@ -13410,7 +13410,7 @@
         </p:nvSpPr>
         <p:spPr>
           <a:xfrm>
-            <a:off x="8778240" y="4645152"/>
+            <a:off x="8823960" y="5084064"/>
             <a:ext cx="548640" cy="201168"/>
           </a:xfrm>
           <a:prstGeom prst="rect">
@@ -13427,14 +13427,14 @@
               <a:buNone/>
             </a:pPr>
             <a:r>
-              <a:rPr lang="en-US" sz="950" dirty="0">
+              <a:rPr lang="en-US" sz="900" dirty="0">
                 <a:solidFill>
                   <a:srgbClr val="5E5E5E"/>
                 </a:solidFill>
               </a:rPr>
               <a:t>-0.2</a:t>
             </a:r>
-            <a:endParaRPr lang="en-US" sz="950" dirty="0"/>
+            <a:endParaRPr lang="en-US" sz="900" dirty="0"/>
           </a:p>
         </p:txBody>
       </p:sp>
@@ -13446,7 +13446,7 @@
         </p:nvSpPr>
         <p:spPr>
           <a:xfrm>
-            <a:off x="9790652" y="4572000"/>
+            <a:off x="9822085" y="5029200"/>
             <a:ext cx="914" cy="73152"/>
           </a:xfrm>
           <a:prstGeom prst="line">
@@ -13469,7 +13469,7 @@
         </p:nvSpPr>
         <p:spPr>
           <a:xfrm>
-            <a:off x="9516332" y="4645152"/>
+            <a:off x="9547765" y="5084064"/>
             <a:ext cx="548640" cy="201168"/>
           </a:xfrm>
           <a:prstGeom prst="rect">
@@ -13486,14 +13486,14 @@
               <a:buNone/>
             </a:pPr>
             <a:r>
-              <a:rPr lang="en-US" sz="950" dirty="0">
+              <a:rPr lang="en-US" sz="900" dirty="0">
                 <a:solidFill>
                   <a:srgbClr val="5E5E5E"/>
                 </a:solidFill>
               </a:rPr>
               <a:t>-0.1</a:t>
             </a:r>
-            <a:endParaRPr lang="en-US" sz="950" dirty="0"/>
+            <a:endParaRPr lang="en-US" sz="900" dirty="0"/>
           </a:p>
         </p:txBody>
       </p:sp>
@@ -13505,7 +13505,7 @@
         </p:nvSpPr>
         <p:spPr>
           <a:xfrm>
-            <a:off x="10528745" y="4572000"/>
+            <a:off x="10545890" y="5029200"/>
             <a:ext cx="914" cy="73152"/>
           </a:xfrm>
           <a:prstGeom prst="line">
@@ -13528,7 +13528,7 @@
         </p:nvSpPr>
         <p:spPr>
           <a:xfrm>
-            <a:off x="10254425" y="4645152"/>
+            <a:off x="10271570" y="5084064"/>
             <a:ext cx="548640" cy="201168"/>
           </a:xfrm>
           <a:prstGeom prst="rect">
@@ -13545,14 +13545,14 @@
               <a:buNone/>
             </a:pPr>
             <a:r>
-              <a:rPr lang="en-US" sz="950" dirty="0">
+              <a:rPr lang="en-US" sz="900" dirty="0">
                 <a:solidFill>
                   <a:srgbClr val="5E5E5E"/>
                 </a:solidFill>
               </a:rPr>
               <a:t>0.0</a:t>
             </a:r>
-            <a:endParaRPr lang="en-US" sz="950" dirty="0"/>
+            <a:endParaRPr lang="en-US" sz="900" dirty="0"/>
           </a:p>
         </p:txBody>
       </p:sp>
@@ -13564,7 +13564,7 @@
         </p:nvSpPr>
         <p:spPr>
           <a:xfrm>
-            <a:off x="11266837" y="4572000"/>
+            <a:off x="11269694" y="5029200"/>
             <a:ext cx="914" cy="73152"/>
           </a:xfrm>
           <a:prstGeom prst="line">
@@ -13587,7 +13587,7 @@
         </p:nvSpPr>
         <p:spPr>
           <a:xfrm>
-            <a:off x="10992517" y="4645152"/>
+            <a:off x="10995374" y="5084064"/>
             <a:ext cx="548640" cy="201168"/>
           </a:xfrm>
           <a:prstGeom prst="rect">
@@ -13604,14 +13604,14 @@
               <a:buNone/>
             </a:pPr>
             <a:r>
-              <a:rPr lang="en-US" sz="950" dirty="0">
+              <a:rPr lang="en-US" sz="900" dirty="0">
                 <a:solidFill>
                   <a:srgbClr val="5E5E5E"/>
                 </a:solidFill>
               </a:rPr>
               <a:t>0.1</a:t>
             </a:r>
-            <a:endParaRPr lang="en-US" sz="950" dirty="0"/>
+            <a:endParaRPr lang="en-US" sz="900" dirty="0"/>
           </a:p>
         </p:txBody>
       </p:sp>
@@ -13623,8 +13623,8 @@
         </p:nvSpPr>
         <p:spPr>
           <a:xfrm>
-            <a:off x="10528745" y="2286000"/>
-            <a:ext cx="914" cy="2286000"/>
+            <a:off x="10545890" y="2176272"/>
+            <a:ext cx="914" cy="2852928"/>
           </a:xfrm>
           <a:prstGeom prst="line">
             <a:avLst/>
@@ -13646,8 +13646,8 @@
         </p:nvSpPr>
         <p:spPr>
           <a:xfrm>
-            <a:off x="7543800" y="2377440"/>
-            <a:ext cx="1463040" cy="274320"/>
+            <a:off x="7516368" y="2212848"/>
+            <a:ext cx="1554480" cy="237744"/>
           </a:xfrm>
           <a:prstGeom prst="rect">
             <a:avLst/>
@@ -13663,14 +13663,14 @@
               <a:buNone/>
             </a:pPr>
             <a:r>
-              <a:rPr lang="en-US" sz="1000" b="1" dirty="0">
+              <a:rPr lang="en-US" sz="950" b="1" dirty="0">
                 <a:solidFill>
                   <a:srgbClr val="1B1B1B"/>
                 </a:solidFill>
               </a:rPr>
               <a:t>Winner, published</a:t>
             </a:r>
-            <a:endParaRPr lang="en-US" sz="1000" dirty="0"/>
+            <a:endParaRPr lang="en-US" sz="950" dirty="0"/>
           </a:p>
         </p:txBody>
       </p:sp>
@@ -13682,8 +13682,8 @@
         </p:nvSpPr>
         <p:spPr>
           <a:xfrm>
-            <a:off x="9643034" y="2414016"/>
-            <a:ext cx="885711" cy="201168"/>
+            <a:off x="9677324" y="2249424"/>
+            <a:ext cx="868566" cy="164592"/>
           </a:xfrm>
           <a:prstGeom prst="rect">
             <a:avLst/>
@@ -13707,8 +13707,8 @@
         </p:nvSpPr>
         <p:spPr>
           <a:xfrm>
-            <a:off x="11432743" y="2377440"/>
-            <a:ext cx="868680" cy="274320"/>
+            <a:off x="11432743" y="2212848"/>
+            <a:ext cx="731520" cy="237744"/>
           </a:xfrm>
           <a:prstGeom prst="rect">
             <a:avLst/>
@@ -13724,14 +13724,14 @@
               <a:buNone/>
             </a:pPr>
             <a:r>
-              <a:rPr lang="en-US" sz="950" b="1" dirty="0">
+              <a:rPr lang="en-US" sz="900" b="1" dirty="0">
                 <a:solidFill>
                   <a:srgbClr val="1B1B1B"/>
                 </a:solidFill>
               </a:rPr>
               <a:t>-0.12</a:t>
             </a:r>
-            <a:endParaRPr lang="en-US" sz="950" dirty="0"/>
+            <a:endParaRPr lang="en-US" sz="900" dirty="0"/>
           </a:p>
         </p:txBody>
       </p:sp>
@@ -13743,8 +13743,8 @@
         </p:nvSpPr>
         <p:spPr>
           <a:xfrm>
-            <a:off x="7543800" y="2807208"/>
-            <a:ext cx="1463040" cy="274320"/>
+            <a:off x="7516368" y="2487168"/>
+            <a:ext cx="1554480" cy="237744"/>
           </a:xfrm>
           <a:prstGeom prst="rect">
             <a:avLst/>
@@ -13760,27 +13760,341 @@
               <a:buNone/>
             </a:pPr>
             <a:r>
-              <a:rPr lang="en-US" sz="1000" b="1" dirty="0">
+              <a:rPr lang="en-US" sz="950" dirty="0">
                 <a:solidFill>
                   <a:srgbClr val="1B1B1B"/>
                 </a:solidFill>
               </a:rPr>
-              <a:t>This project, 20 models</a:t>
-            </a:r>
-            <a:endParaRPr lang="en-US" sz="1000" dirty="0"/>
-          </a:p>
-        </p:txBody>
-      </p:sp>
-      <p:sp>
-        <p:nvSpPr>
-          <p:cNvPr id="36" name="range band"/>
+              <a:t>Logistic regression</a:t>
+            </a:r>
+            <a:endParaRPr lang="en-US" sz="950" dirty="0"/>
+          </a:p>
+        </p:txBody>
+      </p:sp>
+      <p:sp>
+        <p:nvSpPr>
+          <p:cNvPr id="36" name="bar"/>
           <p:cNvSpPr/>
           <p:nvPr/>
         </p:nvSpPr>
         <p:spPr>
           <a:xfrm>
-            <a:off x="10307317" y="2843784"/>
-            <a:ext cx="516665" cy="201168"/>
+            <a:off x="9460182" y="2523744"/>
+            <a:ext cx="1085707" cy="164592"/>
+          </a:xfrm>
+          <a:prstGeom prst="rect">
+            <a:avLst/>
+          </a:prstGeom>
+          <a:solidFill>
+            <a:srgbClr val="8C8C8C"/>
+          </a:solidFill>
+          <a:ln w="12700">
+            <a:solidFill>
+              <a:srgbClr val="8C8C8C"/>
+            </a:solidFill>
+            <a:prstDash val="solid"/>
+          </a:ln>
+        </p:spPr>
+      </p:sp>
+      <p:sp>
+        <p:nvSpPr>
+          <p:cNvPr id="37" name="text"/>
+          <p:cNvSpPr txBox="1"/>
+          <p:nvPr/>
+        </p:nvSpPr>
+        <p:spPr>
+          <a:xfrm>
+            <a:off x="11432743" y="2487168"/>
+            <a:ext cx="731520" cy="237744"/>
+          </a:xfrm>
+          <a:prstGeom prst="rect">
+            <a:avLst/>
+          </a:prstGeom>
+          <a:noFill/>
+          <a:ln/>
+        </p:spPr>
+        <p:txBody>
+          <a:bodyPr wrap="square" lIns="0" tIns="0" rIns="0" bIns="0" rtlCol="0" anchor="ctr"/>
+          <a:lstStyle/>
+          <a:p>
+            <a:pPr algn="l" indent="0" marL="0">
+              <a:buNone/>
+            </a:pPr>
+            <a:r>
+              <a:rPr lang="en-US" sz="900" b="1" dirty="0">
+                <a:solidFill>
+                  <a:srgbClr val="C8102E"/>
+                </a:solidFill>
+              </a:rPr>
+              <a:t>-0.15</a:t>
+            </a:r>
+            <a:endParaRPr lang="en-US" sz="900" dirty="0"/>
+          </a:p>
+        </p:txBody>
+      </p:sp>
+      <p:sp>
+        <p:nvSpPr>
+          <p:cNvPr id="38" name="text"/>
+          <p:cNvSpPr txBox="1"/>
+          <p:nvPr/>
+        </p:nvSpPr>
+        <p:spPr>
+          <a:xfrm>
+            <a:off x="7516368" y="2761488"/>
+            <a:ext cx="1554480" cy="237744"/>
+          </a:xfrm>
+          <a:prstGeom prst="rect">
+            <a:avLst/>
+          </a:prstGeom>
+          <a:noFill/>
+          <a:ln/>
+        </p:spPr>
+        <p:txBody>
+          <a:bodyPr wrap="square" lIns="0" tIns="0" rIns="0" bIns="0" rtlCol="0" anchor="ctr"/>
+          <a:lstStyle/>
+          <a:p>
+            <a:pPr algn="l" indent="0" marL="0">
+              <a:buNone/>
+            </a:pPr>
+            <a:r>
+              <a:rPr lang="en-US" sz="950" dirty="0">
+                <a:solidFill>
+                  <a:srgbClr val="1B1B1B"/>
+                </a:solidFill>
+              </a:rPr>
+              <a:t>Boosted trees</a:t>
+            </a:r>
+            <a:endParaRPr lang="en-US" sz="950" dirty="0"/>
+          </a:p>
+        </p:txBody>
+      </p:sp>
+      <p:sp>
+        <p:nvSpPr>
+          <p:cNvPr id="39" name="ci"/>
+          <p:cNvSpPr/>
+          <p:nvPr/>
+        </p:nvSpPr>
+        <p:spPr>
+          <a:xfrm>
+            <a:off x="10545890" y="2880360"/>
+            <a:ext cx="217141" cy="914"/>
+          </a:xfrm>
+          <a:prstGeom prst="line">
+            <a:avLst/>
+          </a:prstGeom>
+          <a:noFill/>
+          <a:ln w="19050">
+            <a:solidFill>
+              <a:srgbClr val="8C8C8C"/>
+            </a:solidFill>
+            <a:prstDash val="solid"/>
+          </a:ln>
+        </p:spPr>
+      </p:sp>
+      <p:sp>
+        <p:nvSpPr>
+          <p:cNvPr id="40" name="point"/>
+          <p:cNvSpPr/>
+          <p:nvPr/>
+        </p:nvSpPr>
+        <p:spPr>
+          <a:xfrm>
+            <a:off x="10572550" y="2834640"/>
+            <a:ext cx="91440" cy="91440"/>
+          </a:xfrm>
+          <a:prstGeom prst="rect">
+            <a:avLst/>
+          </a:prstGeom>
+          <a:solidFill>
+            <a:srgbClr val="8C8C8C"/>
+          </a:solidFill>
+          <a:ln w="12700">
+            <a:solidFill>
+              <a:srgbClr val="8C8C8C"/>
+            </a:solidFill>
+            <a:prstDash val="solid"/>
+          </a:ln>
+        </p:spPr>
+      </p:sp>
+      <p:sp>
+        <p:nvSpPr>
+          <p:cNvPr id="41" name="text"/>
+          <p:cNvSpPr txBox="1"/>
+          <p:nvPr/>
+        </p:nvSpPr>
+        <p:spPr>
+          <a:xfrm>
+            <a:off x="11432743" y="2761488"/>
+            <a:ext cx="731520" cy="237744"/>
+          </a:xfrm>
+          <a:prstGeom prst="rect">
+            <a:avLst/>
+          </a:prstGeom>
+          <a:noFill/>
+          <a:ln/>
+        </p:spPr>
+        <p:txBody>
+          <a:bodyPr wrap="square" lIns="0" tIns="0" rIns="0" bIns="0" rtlCol="0" anchor="ctr"/>
+          <a:lstStyle/>
+          <a:p>
+            <a:pPr algn="l" indent="0" marL="0">
+              <a:buNone/>
+            </a:pPr>
+            <a:r>
+              <a:rPr lang="en-US" sz="900" b="1" dirty="0">
+                <a:solidFill>
+                  <a:srgbClr val="C8102E"/>
+                </a:solidFill>
+              </a:rPr>
+              <a:t>0.01</a:t>
+            </a:r>
+            <a:endParaRPr lang="en-US" sz="900" dirty="0"/>
+          </a:p>
+        </p:txBody>
+      </p:sp>
+      <p:sp>
+        <p:nvSpPr>
+          <p:cNvPr id="42" name="text"/>
+          <p:cNvSpPr txBox="1"/>
+          <p:nvPr/>
+        </p:nvSpPr>
+        <p:spPr>
+          <a:xfrm>
+            <a:off x="7516368" y="3035808"/>
+            <a:ext cx="1554480" cy="237744"/>
+          </a:xfrm>
+          <a:prstGeom prst="rect">
+            <a:avLst/>
+          </a:prstGeom>
+          <a:noFill/>
+          <a:ln/>
+        </p:spPr>
+        <p:txBody>
+          <a:bodyPr wrap="square" lIns="0" tIns="0" rIns="0" bIns="0" rtlCol="0" anchor="ctr"/>
+          <a:lstStyle/>
+          <a:p>
+            <a:pPr algn="l" indent="0" marL="0">
+              <a:buNone/>
+            </a:pPr>
+            <a:r>
+              <a:rPr lang="en-US" sz="950" dirty="0">
+                <a:solidFill>
+                  <a:srgbClr val="1B1B1B"/>
+                </a:solidFill>
+              </a:rPr>
+              <a:t>Winner's approach</a:t>
+            </a:r>
+            <a:endParaRPr lang="en-US" sz="950" dirty="0"/>
+          </a:p>
+        </p:txBody>
+      </p:sp>
+      <p:sp>
+        <p:nvSpPr>
+          <p:cNvPr id="43" name="bar"/>
+          <p:cNvSpPr/>
+          <p:nvPr/>
+        </p:nvSpPr>
+        <p:spPr>
+          <a:xfrm>
+            <a:off x="10545890" y="3072384"/>
+            <a:ext cx="144761" cy="164592"/>
+          </a:xfrm>
+          <a:prstGeom prst="rect">
+            <a:avLst/>
+          </a:prstGeom>
+          <a:solidFill>
+            <a:srgbClr val="3A3A3A"/>
+          </a:solidFill>
+          <a:ln w="12700">
+            <a:solidFill>
+              <a:srgbClr val="3A3A3A"/>
+            </a:solidFill>
+            <a:prstDash val="solid"/>
+          </a:ln>
+        </p:spPr>
+      </p:sp>
+      <p:sp>
+        <p:nvSpPr>
+          <p:cNvPr id="44" name="text"/>
+          <p:cNvSpPr txBox="1"/>
+          <p:nvPr/>
+        </p:nvSpPr>
+        <p:spPr>
+          <a:xfrm>
+            <a:off x="11432743" y="3035808"/>
+            <a:ext cx="731520" cy="237744"/>
+          </a:xfrm>
+          <a:prstGeom prst="rect">
+            <a:avLst/>
+          </a:prstGeom>
+          <a:noFill/>
+          <a:ln/>
+        </p:spPr>
+        <p:txBody>
+          <a:bodyPr wrap="square" lIns="0" tIns="0" rIns="0" bIns="0" rtlCol="0" anchor="ctr"/>
+          <a:lstStyle/>
+          <a:p>
+            <a:pPr algn="l" indent="0" marL="0">
+              <a:buNone/>
+            </a:pPr>
+            <a:r>
+              <a:rPr lang="en-US" sz="900" b="1" dirty="0">
+                <a:solidFill>
+                  <a:srgbClr val="C8102E"/>
+                </a:solidFill>
+              </a:rPr>
+              <a:t>0.02</a:t>
+            </a:r>
+            <a:endParaRPr lang="en-US" sz="900" dirty="0"/>
+          </a:p>
+        </p:txBody>
+      </p:sp>
+      <p:sp>
+        <p:nvSpPr>
+          <p:cNvPr id="45" name="text"/>
+          <p:cNvSpPr txBox="1"/>
+          <p:nvPr/>
+        </p:nvSpPr>
+        <p:spPr>
+          <a:xfrm>
+            <a:off x="7516368" y="3310128"/>
+            <a:ext cx="1554480" cy="237744"/>
+          </a:xfrm>
+          <a:prstGeom prst="rect">
+            <a:avLst/>
+          </a:prstGeom>
+          <a:noFill/>
+          <a:ln/>
+        </p:spPr>
+        <p:txBody>
+          <a:bodyPr wrap="square" lIns="0" tIns="0" rIns="0" bIns="0" rtlCol="0" anchor="ctr"/>
+          <a:lstStyle/>
+          <a:p>
+            <a:pPr algn="l" indent="0" marL="0">
+              <a:buNone/>
+            </a:pPr>
+            <a:r>
+              <a:rPr lang="en-US" sz="950" dirty="0">
+                <a:solidFill>
+                  <a:srgbClr val="1B1B1B"/>
+                </a:solidFill>
+              </a:rPr>
+              <a:t>Temporal CNN</a:t>
+            </a:r>
+            <a:endParaRPr lang="en-US" sz="950" dirty="0"/>
+          </a:p>
+        </p:txBody>
+      </p:sp>
+      <p:sp>
+        <p:nvSpPr>
+          <p:cNvPr id="46" name="bar"/>
+          <p:cNvSpPr/>
+          <p:nvPr/>
+        </p:nvSpPr>
+        <p:spPr>
+          <a:xfrm>
+            <a:off x="10545890" y="3346704"/>
+            <a:ext cx="72380" cy="164592"/>
           </a:xfrm>
           <a:prstGeom prst="rect">
             <a:avLst/>
@@ -13798,14 +14112,14 @@
       </p:sp>
       <p:sp>
         <p:nvSpPr>
-          <p:cNvPr id="37" name="text"/>
+          <p:cNvPr id="47" name="text"/>
           <p:cNvSpPr txBox="1"/>
           <p:nvPr/>
         </p:nvSpPr>
         <p:spPr>
           <a:xfrm>
-            <a:off x="11432743" y="2807208"/>
-            <a:ext cx="868680" cy="274320"/>
+            <a:off x="11432743" y="3310128"/>
+            <a:ext cx="731520" cy="237744"/>
           </a:xfrm>
           <a:prstGeom prst="rect">
             <a:avLst/>
@@ -13821,12 +14135,48 @@
               <a:buNone/>
             </a:pPr>
             <a:r>
-              <a:rPr lang="en-US" sz="950" b="1" dirty="0">
+              <a:rPr lang="en-US" sz="900" b="1" dirty="0">
                 <a:solidFill>
                   <a:srgbClr val="C8102E"/>
                 </a:solidFill>
               </a:rPr>
-              <a:t>-0.03 to +0.04</a:t>
+              <a:t>0.01</a:t>
+            </a:r>
+            <a:endParaRPr lang="en-US" sz="900" dirty="0"/>
+          </a:p>
+        </p:txBody>
+      </p:sp>
+      <p:sp>
+        <p:nvSpPr>
+          <p:cNvPr id="48" name="text"/>
+          <p:cNvSpPr txBox="1"/>
+          <p:nvPr/>
+        </p:nvSpPr>
+        <p:spPr>
+          <a:xfrm>
+            <a:off x="7516368" y="3584448"/>
+            <a:ext cx="1554480" cy="237744"/>
+          </a:xfrm>
+          <a:prstGeom prst="rect">
+            <a:avLst/>
+          </a:prstGeom>
+          <a:noFill/>
+          <a:ln/>
+        </p:spPr>
+        <p:txBody>
+          <a:bodyPr wrap="square" lIns="0" tIns="0" rIns="0" bIns="0" rtlCol="0" anchor="ctr"/>
+          <a:lstStyle/>
+          <a:p>
+            <a:pPr algn="l" indent="0" marL="0">
+              <a:buNone/>
+            </a:pPr>
+            <a:r>
+              <a:rPr lang="en-US" sz="950" dirty="0">
+                <a:solidFill>
+                  <a:srgbClr val="1B1B1B"/>
+                </a:solidFill>
+              </a:rPr>
+              <a:t>GRU-D</a:t>
             </a:r>
             <a:endParaRPr lang="en-US" sz="950" dirty="0"/>
           </a:p>
@@ -13834,50 +14184,14 @@
       </p:sp>
       <p:sp>
         <p:nvSpPr>
-          <p:cNvPr id="38" name="text"/>
-          <p:cNvSpPr txBox="1"/>
-          <p:nvPr/>
-        </p:nvSpPr>
-        <p:spPr>
-          <a:xfrm>
-            <a:off x="7543800" y="3236976"/>
-            <a:ext cx="1463040" cy="274320"/>
-          </a:xfrm>
-          <a:prstGeom prst="rect">
-            <a:avLst/>
-          </a:prstGeom>
-          <a:noFill/>
-          <a:ln/>
-        </p:spPr>
-        <p:txBody>
-          <a:bodyPr wrap="square" lIns="0" tIns="0" rIns="0" bIns="0" rtlCol="0" anchor="ctr"/>
-          <a:lstStyle/>
-          <a:p>
-            <a:pPr algn="l" indent="0" marL="0">
-              <a:buNone/>
-            </a:pPr>
-            <a:r>
-              <a:rPr lang="en-US" sz="1000" dirty="0">
-                <a:solidFill>
-                  <a:srgbClr val="1B1B1B"/>
-                </a:solidFill>
-              </a:rPr>
-              <a:t>GRU-D</a:t>
-            </a:r>
-            <a:endParaRPr lang="en-US" sz="1000" dirty="0"/>
-          </a:p>
-        </p:txBody>
-      </p:sp>
-      <p:sp>
-        <p:nvSpPr>
-          <p:cNvPr id="39" name="ci"/>
+          <p:cNvPr id="49" name="ci"/>
           <p:cNvSpPr/>
           <p:nvPr/>
         </p:nvSpPr>
         <p:spPr>
           <a:xfrm>
-            <a:off x="10233508" y="3374136"/>
-            <a:ext cx="738092" cy="914"/>
+            <a:off x="10256368" y="3703320"/>
+            <a:ext cx="723805" cy="914"/>
           </a:xfrm>
           <a:prstGeom prst="line">
             <a:avLst/>
@@ -13893,13 +14207,13 @@
       </p:sp>
       <p:sp>
         <p:nvSpPr>
-          <p:cNvPr id="40" name="point"/>
+          <p:cNvPr id="50" name="point"/>
           <p:cNvSpPr/>
           <p:nvPr/>
         </p:nvSpPr>
         <p:spPr>
           <a:xfrm>
-            <a:off x="10556834" y="3328416"/>
+            <a:off x="10572550" y="3657600"/>
             <a:ext cx="91440" cy="91440"/>
           </a:xfrm>
           <a:prstGeom prst="rect">
@@ -13918,14 +14232,14 @@
       </p:sp>
       <p:sp>
         <p:nvSpPr>
-          <p:cNvPr id="41" name="text"/>
+          <p:cNvPr id="51" name="text"/>
           <p:cNvSpPr txBox="1"/>
           <p:nvPr/>
         </p:nvSpPr>
         <p:spPr>
           <a:xfrm>
-            <a:off x="11432743" y="3236976"/>
-            <a:ext cx="868680" cy="274320"/>
+            <a:off x="11432743" y="3584448"/>
+            <a:ext cx="731520" cy="237744"/>
           </a:xfrm>
           <a:prstGeom prst="rect">
             <a:avLst/>
@@ -13941,86 +14255,63 @@
               <a:buNone/>
             </a:pPr>
             <a:r>
-              <a:rPr lang="en-US" sz="950" b="1" dirty="0">
+              <a:rPr lang="en-US" sz="900" b="1" dirty="0">
                 <a:solidFill>
                   <a:srgbClr val="C8102E"/>
                 </a:solidFill>
               </a:rPr>
               <a:t>0.01</a:t>
             </a:r>
+            <a:endParaRPr lang="en-US" sz="900" dirty="0"/>
+          </a:p>
+        </p:txBody>
+      </p:sp>
+      <p:sp>
+        <p:nvSpPr>
+          <p:cNvPr id="52" name="text"/>
+          <p:cNvSpPr txBox="1"/>
+          <p:nvPr/>
+        </p:nvSpPr>
+        <p:spPr>
+          <a:xfrm>
+            <a:off x="7516368" y="3858768"/>
+            <a:ext cx="1554480" cy="237744"/>
+          </a:xfrm>
+          <a:prstGeom prst="rect">
+            <a:avLst/>
+          </a:prstGeom>
+          <a:noFill/>
+          <a:ln/>
+        </p:spPr>
+        <p:txBody>
+          <a:bodyPr wrap="square" lIns="0" tIns="0" rIns="0" bIns="0" rtlCol="0" anchor="ctr"/>
+          <a:lstStyle/>
+          <a:p>
+            <a:pPr algn="l" indent="0" marL="0">
+              <a:buNone/>
+            </a:pPr>
+            <a:r>
+              <a:rPr lang="en-US" sz="950" dirty="0">
+                <a:solidFill>
+                  <a:srgbClr val="1B1B1B"/>
+                </a:solidFill>
+              </a:rPr>
+              <a:t>Flat OSTA</a:t>
+            </a:r>
             <a:endParaRPr lang="en-US" sz="950" dirty="0"/>
           </a:p>
         </p:txBody>
       </p:sp>
       <p:sp>
         <p:nvSpPr>
-          <p:cNvPr id="42" name="text"/>
-          <p:cNvSpPr txBox="1"/>
-          <p:nvPr/>
-        </p:nvSpPr>
-        <p:spPr>
-          <a:xfrm>
-            <a:off x="7543800" y="3666744"/>
-            <a:ext cx="1463040" cy="274320"/>
-          </a:xfrm>
-          <a:prstGeom prst="rect">
-            <a:avLst/>
-          </a:prstGeom>
-          <a:noFill/>
-          <a:ln/>
-        </p:spPr>
-        <p:txBody>
-          <a:bodyPr wrap="square" lIns="0" tIns="0" rIns="0" bIns="0" rtlCol="0" anchor="ctr"/>
-          <a:lstStyle/>
-          <a:p>
-            <a:pPr algn="l" indent="0" marL="0">
-              <a:buNone/>
-            </a:pPr>
-            <a:r>
-              <a:rPr lang="en-US" sz="1000" dirty="0">
-                <a:solidFill>
-                  <a:srgbClr val="1B1B1B"/>
-                </a:solidFill>
-              </a:rPr>
-              <a:t>CNN to OSTA</a:t>
-            </a:r>
-            <a:endParaRPr lang="en-US" sz="1000" dirty="0"/>
-          </a:p>
-        </p:txBody>
-      </p:sp>
-      <p:sp>
-        <p:nvSpPr>
-          <p:cNvPr id="43" name="ci"/>
+          <p:cNvPr id="53" name="bar"/>
           <p:cNvSpPr/>
           <p:nvPr/>
         </p:nvSpPr>
         <p:spPr>
           <a:xfrm>
-            <a:off x="10454935" y="3803904"/>
-            <a:ext cx="369046" cy="914"/>
-          </a:xfrm>
-          <a:prstGeom prst="line">
-            <a:avLst/>
-          </a:prstGeom>
-          <a:noFill/>
-          <a:ln w="19050">
-            <a:solidFill>
-              <a:srgbClr val="C8102E"/>
-            </a:solidFill>
-            <a:prstDash val="solid"/>
-          </a:ln>
-        </p:spPr>
-      </p:sp>
-      <p:sp>
-        <p:nvSpPr>
-          <p:cNvPr id="44" name="point"/>
-          <p:cNvSpPr/>
-          <p:nvPr/>
-        </p:nvSpPr>
-        <p:spPr>
-          <a:xfrm>
-            <a:off x="10630643" y="3758184"/>
-            <a:ext cx="91440" cy="91440"/>
+            <a:off x="10545890" y="3895344"/>
+            <a:ext cx="217141" cy="164592"/>
           </a:xfrm>
           <a:prstGeom prst="rect">
             <a:avLst/>
@@ -14038,14 +14329,14 @@
       </p:sp>
       <p:sp>
         <p:nvSpPr>
-          <p:cNvPr id="45" name="text"/>
+          <p:cNvPr id="54" name="text"/>
           <p:cNvSpPr txBox="1"/>
           <p:nvPr/>
         </p:nvSpPr>
         <p:spPr>
           <a:xfrm>
-            <a:off x="11432743" y="3666744"/>
-            <a:ext cx="868680" cy="274320"/>
+            <a:off x="11432743" y="3858768"/>
+            <a:ext cx="731520" cy="237744"/>
           </a:xfrm>
           <a:prstGeom prst="rect">
             <a:avLst/>
@@ -14061,12 +14352,48 @@
               <a:buNone/>
             </a:pPr>
             <a:r>
-              <a:rPr lang="en-US" sz="950" b="1" dirty="0">
+              <a:rPr lang="en-US" sz="900" b="1" dirty="0">
                 <a:solidFill>
                   <a:srgbClr val="C8102E"/>
                 </a:solidFill>
               </a:rPr>
-              <a:t>0.02</a:t>
+              <a:t>0.03</a:t>
+            </a:r>
+            <a:endParaRPr lang="en-US" sz="900" dirty="0"/>
+          </a:p>
+        </p:txBody>
+      </p:sp>
+      <p:sp>
+        <p:nvSpPr>
+          <p:cNvPr id="55" name="text"/>
+          <p:cNvSpPr txBox="1"/>
+          <p:nvPr/>
+        </p:nvSpPr>
+        <p:spPr>
+          <a:xfrm>
+            <a:off x="7516368" y="4133088"/>
+            <a:ext cx="1554480" cy="237744"/>
+          </a:xfrm>
+          <a:prstGeom prst="rect">
+            <a:avLst/>
+          </a:prstGeom>
+          <a:noFill/>
+          <a:ln/>
+        </p:spPr>
+        <p:txBody>
+          <a:bodyPr wrap="square" lIns="0" tIns="0" rIns="0" bIns="0" rtlCol="0" anchor="ctr"/>
+          <a:lstStyle/>
+          <a:p>
+            <a:pPr algn="l" indent="0" marL="0">
+              <a:buNone/>
+            </a:pPr>
+            <a:r>
+              <a:rPr lang="en-US" sz="950" dirty="0">
+                <a:solidFill>
+                  <a:srgbClr val="1B1B1B"/>
+                </a:solidFill>
+              </a:rPr>
+              <a:t>OSTA</a:t>
             </a:r>
             <a:endParaRPr lang="en-US" sz="950" dirty="0"/>
           </a:p>
@@ -14074,58 +14401,24 @@
       </p:sp>
       <p:sp>
         <p:nvSpPr>
-          <p:cNvPr id="46" name="text"/>
-          <p:cNvSpPr txBox="1"/>
-          <p:nvPr/>
-        </p:nvSpPr>
-        <p:spPr>
-          <a:xfrm>
-            <a:off x="7543800" y="4096512"/>
-            <a:ext cx="1463040" cy="274320"/>
-          </a:xfrm>
-          <a:prstGeom prst="rect">
-            <a:avLst/>
-          </a:prstGeom>
-          <a:noFill/>
-          <a:ln/>
-        </p:spPr>
-        <p:txBody>
-          <a:bodyPr wrap="square" lIns="0" tIns="0" rIns="0" bIns="0" rtlCol="0" anchor="ctr"/>
-          <a:lstStyle/>
-          <a:p>
-            <a:pPr algn="l" indent="0" marL="0">
-              <a:buNone/>
-            </a:pPr>
-            <a:r>
-              <a:rPr lang="en-US" sz="1000" dirty="0">
-                <a:solidFill>
-                  <a:srgbClr val="1B1B1B"/>
-                </a:solidFill>
-              </a:rPr>
-              <a:t>Boosted trees</a:t>
-            </a:r>
-            <a:endParaRPr lang="en-US" sz="1000" dirty="0"/>
-          </a:p>
-        </p:txBody>
-      </p:sp>
-      <p:sp>
-        <p:nvSpPr>
-          <p:cNvPr id="47" name="ci"/>
+          <p:cNvPr id="56" name="bar"/>
           <p:cNvSpPr/>
           <p:nvPr/>
         </p:nvSpPr>
         <p:spPr>
           <a:xfrm>
-            <a:off x="10528745" y="4233672"/>
-            <a:ext cx="221428" cy="914"/>
-          </a:xfrm>
-          <a:prstGeom prst="line">
-            <a:avLst/>
-          </a:prstGeom>
-          <a:noFill/>
-          <a:ln w="19050">
+            <a:off x="10545890" y="4169664"/>
+            <a:ext cx="289522" cy="164592"/>
+          </a:xfrm>
+          <a:prstGeom prst="rect">
+            <a:avLst/>
+          </a:prstGeom>
+          <a:solidFill>
+            <a:srgbClr val="C8102E"/>
+          </a:solidFill>
+          <a:ln w="12700">
             <a:solidFill>
-              <a:srgbClr val="8C8C8C"/>
+              <a:srgbClr val="C8102E"/>
             </a:solidFill>
             <a:prstDash val="solid"/>
           </a:ln>
@@ -14133,24 +14426,96 @@
       </p:sp>
       <p:sp>
         <p:nvSpPr>
-          <p:cNvPr id="48" name="point"/>
+          <p:cNvPr id="57" name="text"/>
+          <p:cNvSpPr txBox="1"/>
+          <p:nvPr/>
+        </p:nvSpPr>
+        <p:spPr>
+          <a:xfrm>
+            <a:off x="11432743" y="4133088"/>
+            <a:ext cx="731520" cy="237744"/>
+          </a:xfrm>
+          <a:prstGeom prst="rect">
+            <a:avLst/>
+          </a:prstGeom>
+          <a:noFill/>
+          <a:ln/>
+        </p:spPr>
+        <p:txBody>
+          <a:bodyPr wrap="square" lIns="0" tIns="0" rIns="0" bIns="0" rtlCol="0" anchor="ctr"/>
+          <a:lstStyle/>
+          <a:p>
+            <a:pPr algn="l" indent="0" marL="0">
+              <a:buNone/>
+            </a:pPr>
+            <a:r>
+              <a:rPr lang="en-US" sz="900" b="1" dirty="0">
+                <a:solidFill>
+                  <a:srgbClr val="C8102E"/>
+                </a:solidFill>
+              </a:rPr>
+              <a:t>0.04</a:t>
+            </a:r>
+            <a:endParaRPr lang="en-US" sz="900" dirty="0"/>
+          </a:p>
+        </p:txBody>
+      </p:sp>
+      <p:sp>
+        <p:nvSpPr>
+          <p:cNvPr id="58" name="text"/>
+          <p:cNvSpPr txBox="1"/>
+          <p:nvPr/>
+        </p:nvSpPr>
+        <p:spPr>
+          <a:xfrm>
+            <a:off x="7516368" y="4407408"/>
+            <a:ext cx="1554480" cy="237744"/>
+          </a:xfrm>
+          <a:prstGeom prst="rect">
+            <a:avLst/>
+          </a:prstGeom>
+          <a:noFill/>
+          <a:ln/>
+        </p:spPr>
+        <p:txBody>
+          <a:bodyPr wrap="square" lIns="0" tIns="0" rIns="0" bIns="0" rtlCol="0" anchor="ctr"/>
+          <a:lstStyle/>
+          <a:p>
+            <a:pPr algn="l" indent="0" marL="0">
+              <a:buNone/>
+            </a:pPr>
+            <a:r>
+              <a:rPr lang="en-US" sz="950" dirty="0">
+                <a:solidFill>
+                  <a:srgbClr val="1B1B1B"/>
+                </a:solidFill>
+              </a:rPr>
+              <a:t>SSL CNN to OSTA</a:t>
+            </a:r>
+            <a:endParaRPr lang="en-US" sz="950" dirty="0"/>
+          </a:p>
+        </p:txBody>
+      </p:sp>
+      <p:sp>
+        <p:nvSpPr>
+          <p:cNvPr id="59" name="bar"/>
           <p:cNvSpPr/>
           <p:nvPr/>
         </p:nvSpPr>
         <p:spPr>
           <a:xfrm>
-            <a:off x="10556834" y="4187952"/>
-            <a:ext cx="91440" cy="91440"/>
+            <a:off x="10545890" y="4443984"/>
+            <a:ext cx="289522" cy="164592"/>
           </a:xfrm>
           <a:prstGeom prst="rect">
             <a:avLst/>
           </a:prstGeom>
           <a:solidFill>
-            <a:srgbClr val="8C8C8C"/>
+            <a:srgbClr val="C8102E"/>
           </a:solidFill>
           <a:ln w="12700">
             <a:solidFill>
-              <a:srgbClr val="8C8C8C"/>
+              <a:srgbClr val="C8102E"/>
             </a:solidFill>
             <a:prstDash val="solid"/>
           </a:ln>
@@ -14158,14 +14523,14 @@
       </p:sp>
       <p:sp>
         <p:nvSpPr>
-          <p:cNvPr id="49" name="text"/>
+          <p:cNvPr id="60" name="text"/>
           <p:cNvSpPr txBox="1"/>
           <p:nvPr/>
         </p:nvSpPr>
         <p:spPr>
           <a:xfrm>
-            <a:off x="11432743" y="4096512"/>
-            <a:ext cx="868680" cy="274320"/>
+            <a:off x="11432743" y="4407408"/>
+            <a:ext cx="731520" cy="237744"/>
           </a:xfrm>
           <a:prstGeom prst="rect">
             <a:avLst/>
@@ -14181,12 +14546,145 @@
               <a:buNone/>
             </a:pPr>
             <a:r>
+              <a:rPr lang="en-US" sz="900" b="1" dirty="0">
+                <a:solidFill>
+                  <a:srgbClr val="C8102E"/>
+                </a:solidFill>
+              </a:rPr>
+              <a:t>0.04</a:t>
+            </a:r>
+            <a:endParaRPr lang="en-US" sz="900" dirty="0"/>
+          </a:p>
+        </p:txBody>
+      </p:sp>
+      <p:sp>
+        <p:nvSpPr>
+          <p:cNvPr id="61" name="text"/>
+          <p:cNvSpPr txBox="1"/>
+          <p:nvPr/>
+        </p:nvSpPr>
+        <p:spPr>
+          <a:xfrm>
+            <a:off x="7516368" y="4681728"/>
+            <a:ext cx="1554480" cy="237744"/>
+          </a:xfrm>
+          <a:prstGeom prst="rect">
+            <a:avLst/>
+          </a:prstGeom>
+          <a:noFill/>
+          <a:ln/>
+        </p:spPr>
+        <p:txBody>
+          <a:bodyPr wrap="square" lIns="0" tIns="0" rIns="0" bIns="0" rtlCol="0" anchor="ctr"/>
+          <a:lstStyle/>
+          <a:p>
+            <a:pPr algn="l" indent="0" marL="0">
+              <a:buNone/>
+            </a:pPr>
+            <a:r>
               <a:rPr lang="en-US" sz="950" b="1" dirty="0">
                 <a:solidFill>
+                  <a:srgbClr val="1B1B1B"/>
+                </a:solidFill>
+              </a:rPr>
+              <a:t>eICU models at home (21)</a:t>
+            </a:r>
+            <a:endParaRPr lang="en-US" sz="950" dirty="0"/>
+          </a:p>
+        </p:txBody>
+      </p:sp>
+      <p:sp>
+        <p:nvSpPr>
+          <p:cNvPr id="62" name="range band"/>
+          <p:cNvSpPr/>
+          <p:nvPr/>
+        </p:nvSpPr>
+        <p:spPr>
+          <a:xfrm>
+            <a:off x="10545890" y="4718304"/>
+            <a:ext cx="579044" cy="164592"/>
+          </a:xfrm>
+          <a:prstGeom prst="rect">
+            <a:avLst/>
+          </a:prstGeom>
+          <a:solidFill>
+            <a:srgbClr val="F0A8A8"/>
+          </a:solidFill>
+          <a:ln w="12700">
+            <a:solidFill>
+              <a:srgbClr val="F0A8A8"/>
+            </a:solidFill>
+            <a:prstDash val="solid"/>
+          </a:ln>
+        </p:spPr>
+      </p:sp>
+      <p:sp>
+        <p:nvSpPr>
+          <p:cNvPr id="63" name="text"/>
+          <p:cNvSpPr txBox="1"/>
+          <p:nvPr/>
+        </p:nvSpPr>
+        <p:spPr>
+          <a:xfrm>
+            <a:off x="11432743" y="4681728"/>
+            <a:ext cx="731520" cy="237744"/>
+          </a:xfrm>
+          <a:prstGeom prst="rect">
+            <a:avLst/>
+          </a:prstGeom>
+          <a:noFill/>
+          <a:ln/>
+        </p:spPr>
+        <p:txBody>
+          <a:bodyPr wrap="square" lIns="0" tIns="0" rIns="0" bIns="0" rtlCol="0" anchor="ctr"/>
+          <a:lstStyle/>
+          <a:p>
+            <a:pPr algn="l" indent="0" marL="0">
+              <a:buNone/>
+            </a:pPr>
+            <a:r>
+              <a:rPr lang="en-US" sz="900" b="1" dirty="0">
+                <a:solidFill>
                   <a:srgbClr val="C8102E"/>
                 </a:solidFill>
               </a:rPr>
-              <a:t>0.01</a:t>
+              <a:t>0.00 to 0.08</a:t>
+            </a:r>
+            <a:endParaRPr lang="en-US" sz="900" dirty="0"/>
+          </a:p>
+        </p:txBody>
+      </p:sp>
+      <p:sp>
+        <p:nvSpPr>
+          <p:cNvPr id="64" name="text"/>
+          <p:cNvSpPr txBox="1"/>
+          <p:nvPr/>
+        </p:nvSpPr>
+        <p:spPr>
+          <a:xfrm>
+            <a:off x="7543800" y="5321808"/>
+            <a:ext cx="3962095" cy="566928"/>
+          </a:xfrm>
+          <a:prstGeom prst="rect">
+            <a:avLst/>
+          </a:prstGeom>
+          <a:noFill/>
+          <a:ln/>
+        </p:spPr>
+        <p:txBody>
+          <a:bodyPr wrap="square" lIns="0" tIns="0" rIns="0" bIns="0" rtlCol="0" anchor="t"/>
+          <a:lstStyle/>
+          <a:p>
+            <a:pPr algn="l" indent="0" marL="0">
+              <a:buNone/>
+            </a:pPr>
+            <a:r>
+              <a:rPr lang="en-US" sz="950" dirty="0">
+                <a:solidFill>
+                  <a:srgbClr val="5E5E5E"/>
+                </a:solidFill>
+              </a:rPr>
+              <a:t>MIMIC-IV models on eICU: -0.03 to +0.04 across 20 models, CIs include zero where computed. eICU's own models score 0.00 to 0.08 on the same 45 events: away and at home coincide there. The sealed holdout is the real test.</a:t>
             </a:r>
             <a:endParaRPr lang="en-US" sz="950" dirty="0"/>
           </a:p>
@@ -14194,43 +14692,7 @@
       </p:sp>
       <p:sp>
         <p:nvSpPr>
-          <p:cNvPr id="50" name="text"/>
-          <p:cNvSpPr txBox="1"/>
-          <p:nvPr/>
-        </p:nvSpPr>
-        <p:spPr>
-          <a:xfrm>
-            <a:off x="7543800" y="4983480"/>
-            <a:ext cx="3962095" cy="822960"/>
-          </a:xfrm>
-          <a:prstGeom prst="rect">
-            <a:avLst/>
-          </a:prstGeom>
-          <a:noFill/>
-          <a:ln/>
-        </p:spPr>
-        <p:txBody>
-          <a:bodyPr wrap="square" lIns="0" tIns="0" rIns="0" bIns="0" rtlCol="0" anchor="t"/>
-          <a:lstStyle/>
-          <a:p>
-            <a:pPr algn="l" indent="0" marL="0">
-              <a:buNone/>
-            </a:pPr>
-            <a:r>
-              <a:rPr lang="en-US" sz="1000" dirty="0">
-                <a:solidFill>
-                  <a:srgbClr val="5E5E5E"/>
-                </a:solidFill>
-              </a:rPr>
-              <a:t>Range of 20 models; every 95 % CI includes zero; logistic regression -0.15. Not below silence, where the winner was; not shown above it. The sealed holdout is the real test.</a:t>
-            </a:r>
-            <a:endParaRPr lang="en-US" sz="1000" dirty="0"/>
-          </a:p>
-        </p:txBody>
-      </p:sp>
-      <p:sp>
-        <p:nvSpPr>
-          <p:cNvPr id="51" name="references"/>
+          <p:cNvPr id="65" name="references"/>
           <p:cNvSpPr txBox="1"/>
           <p:nvPr/>
         </p:nvSpPr>
@@ -14541,7 +15003,7 @@
         <p:spPr>
           <a:xfrm>
             <a:off x="1143000" y="2176272"/>
-            <a:ext cx="5120640" cy="566928"/>
+            <a:ext cx="5257800" cy="566928"/>
           </a:xfrm>
           <a:prstGeom prst="rect">
             <a:avLst/>
@@ -14662,7 +15124,7 @@
         <p:spPr>
           <a:xfrm>
             <a:off x="1143000" y="3072384"/>
-            <a:ext cx="5120640" cy="566928"/>
+            <a:ext cx="5257800" cy="566928"/>
           </a:xfrm>
           <a:prstGeom prst="rect">
             <a:avLst/>
@@ -14783,7 +15245,7 @@
         <p:spPr>
           <a:xfrm>
             <a:off x="1143000" y="3968496"/>
-            <a:ext cx="5120640" cy="566928"/>
+            <a:ext cx="5257800" cy="566928"/>
           </a:xfrm>
           <a:prstGeom prst="rect">
             <a:avLst/>
@@ -14799,14 +15261,14 @@
               <a:buNone/>
             </a:pPr>
             <a:r>
-              <a:rPr lang="en-US" sz="1250" dirty="0">
+              <a:rPr lang="en-US" sz="1150" dirty="0">
                 <a:solidFill>
                   <a:srgbClr val="5E5E5E"/>
                 </a:solidFill>
               </a:rPr>
-              <a:t>harmonisation recovers the data; on honest data all 21 models stay above zero at home; small samples overfit, so no model is shown best</a:t>
-            </a:r>
-            <a:endParaRPr lang="en-US" sz="1250" dirty="0"/>
+              <a:t>harmonisation recovers the data; all 21 above zero on MIMIC-IV, near zero on eICU at home or transferred; small samples overfit, none shown best</a:t>
+            </a:r>
+            <a:endParaRPr lang="en-US" sz="1150" dirty="0"/>
           </a:p>
         </p:txBody>
       </p:sp>
@@ -14904,7 +15366,7 @@
         <p:spPr>
           <a:xfrm>
             <a:off x="1143000" y="4864608"/>
-            <a:ext cx="5120640" cy="566928"/>
+            <a:ext cx="5257800" cy="566928"/>
           </a:xfrm>
           <a:prstGeom prst="rect">
             <a:avLst/>
@@ -15058,7 +15520,7 @@
                   <a:srgbClr val="1B1B1B"/>
                 </a:solidFill>
               </a:rPr>
-              <a:t>Complete the qualitative study (20 infectious disease and critical care consultants); finish the eICU arm of the model comparison</a:t>
+              <a:t>Complete the qualitative study (20 infectious disease and critical care consultants); fix the full-cohort arms from the MIMIC-IV and eICU shortlists</a:t>
             </a:r>
             <a:endParaRPr lang="en-US" sz="1300" dirty="0"/>
           </a:p>
@@ -16389,7 +16851,7 @@
                   <a:srgbClr val="FFFFFF"/>
                 </a:solidFill>
               </a:rPr>
-              <a:t>On honest, harmonised data, all 21 models keep a positive utility at home [40].</a:t>
+              <a:t>On honest, harmonised data, all 21 models keep a positive utility on MIMIC-IV; on eICU, with 45 events, models trained there and models transferred sit near zero alike [40].</a:t>
             </a:r>
             <a:endParaRPr lang="en-US" sz="1150" dirty="0"/>
           </a:p>
@@ -16407,7 +16869,7 @@
                   <a:srgbClr val="FFFFFF"/>
                 </a:solidFill>
               </a:rPr>
-              <a:t>The project's own organ-grouping idea is not supported at this scale, and is reported as found.</a:t>
+              <a:t>The project's own organ-grouping idea is not supported on either database, and is reported as found.</a:t>
             </a:r>
             <a:endParaRPr lang="en-US" sz="1150" dirty="0"/>
           </a:p>
@@ -16425,7 +16887,7 @@
                   <a:srgbClr val="FFFFFF"/>
                 </a:solidFill>
               </a:rPr>
-              <a:t>Whether a warning travels to an unseen hospital system is the open question: the consultants' study and the sealed holdout answer next.</a:t>
+              <a:t>Whether a warning travels to an unseen hospital system is the open question: the full cohort, the consultants' study and the sealed holdout answer next.</a:t>
             </a:r>
             <a:endParaRPr lang="en-US" sz="1150" dirty="0"/>
           </a:p>
@@ -28753,7 +29215,7 @@
                           <a:ea typeface="Arial" pitchFamily="34" charset="-122"/>
                           <a:cs typeface="Arial" pitchFamily="34" charset="-120"/>
                         </a:rPr>
-                        <a:t>8,795</a:t>
+                        <a:t>8,758</a:t>
                       </a:r>
                       <a:endParaRPr lang="en-US" sz="1150" dirty="0">
                         <a:latin typeface="Arial" charset="0"/>
@@ -29080,7 +29542,7 @@
                           <a:ea typeface="Arial" pitchFamily="34" charset="-122"/>
                           <a:cs typeface="Arial" pitchFamily="34" charset="-120"/>
                         </a:rPr>
-                        <a:t>5,710</a:t>
+                        <a:t>5,623</a:t>
                       </a:r>
                       <a:endParaRPr lang="en-US" sz="1150" dirty="0">
                         <a:latin typeface="Arial" charset="0"/>
@@ -29286,7 +29748,7 @@
                   <a:srgbClr val="1B1B1B"/>
                 </a:solidFill>
               </a:rPr>
-              <a:t>Unlabelled pretraining corpus: 67,455 MIMIC-IV and 75,000 eICU stays outside the cohort and the holdout.</a:t>
+              <a:t>Unlabelled pretraining corpus: 67,193 MIMIC-IV and 74,139 eICU stays outside the cohort and the holdout.</a:t>
             </a:r>
             <a:endParaRPr lang="en-US" sz="1400" dirty="0"/>
           </a:p>

</xml_diff>